<commit_message>
apresentacao: tres slides do porque comprar -- a prova, o resto do argumento e a objecao honesta
Os argumentos viram cartoes, dois slides; a objecao (nenhum projeto WINDEV real
com contrato ainda) ganha slide proprio, porque e o que da credibilidade ao resto.
O numero de videos no slide de prova passa a sair do medidor.

Co-Authored-By: Claude Fable 5.1 <noreply@anthropic.com>
Claude-Session: https://claude.ai/code/session_01VkAtY15TRZZmUZhEcAExdY
</commit_message>
<xml_diff>
--- a/wx-claude-code/docs/apresentacao-wx-claude-code.pptx
+++ b/wx-claude-code/docs/apresentacao-wx-claude-code.pptx
@@ -18,9 +18,12 @@
     <p:sldId id="266" r:id="rId12"/>
     <p:sldId id="267" r:id="rId13"/>
     <p:sldId id="268" r:id="rId14"/>
+    <p:sldId id="269" r:id="rId15"/>
+    <p:sldId id="270" r:id="rId16"/>
+    <p:sldId id="271" r:id="rId17"/>
   </p:sldIdLst>
   <p:notesMasterIdLst>
-    <p:notesMasterId r:id="rId15"/>
+    <p:notesMasterId r:id="rId18"/>
   </p:notesMasterIdLst>
   <p:sldSz cx="12192000" cy="6858000"/>
   <p:notesSz cx="6858000" cy="12192000"/>
@@ -890,6 +893,270 @@
             <a:fld id="{F7021451-1387-4CA6-816F-3879F97B5CBC}" type="slidenum">
               <a:rPr lang="en-US"/>
               <a:t>13</a:t>
+            </a:fld>
+            <a:endParaRPr lang="en-US"/>
+          </a:p>
+        </p:txBody>
+      </p:sp>
+    </p:spTree>
+    <p:extLst>
+      <p:ext uri="{BB962C8B-B14F-4D97-AF65-F5344CB8AC3E}">
+        <p14:creationId xmlns:p14="http://schemas.microsoft.com/office/powerpoint/2010/main" val="1024086991"/>
+      </p:ext>
+    </p:extLst>
+  </p:cSld>
+  <p:clrMapOvr>
+    <a:masterClrMapping/>
+  </p:clrMapOvr>
+</p:notes>
+</file>
+
+<file path=ppt/notesSlides/notesSlide14.xml><?xml version="1.0" encoding="utf-8"?>
+<p:notes xmlns:a="http://schemas.openxmlformats.org/drawingml/2006/main" xmlns:r="http://schemas.openxmlformats.org/officeDocument/2006/relationships" xmlns:p="http://schemas.openxmlformats.org/presentationml/2006/main">
+  <p:cSld>
+    <p:spTree>
+      <p:nvGrpSpPr>
+        <p:cNvPr id="1" name=""/>
+        <p:cNvGrpSpPr/>
+        <p:nvPr/>
+      </p:nvGrpSpPr>
+      <p:grpSpPr>
+        <a:xfrm>
+          <a:off x="0" y="0"/>
+          <a:ext cx="0" cy="0"/>
+          <a:chOff x="0" y="0"/>
+          <a:chExt cx="0" cy="0"/>
+        </a:xfrm>
+      </p:grpSpPr>
+      <p:sp>
+        <p:nvSpPr>
+          <p:cNvPr id="2" name="Slide Image Placeholder 1"/>
+          <p:cNvSpPr>
+            <a:spLocks noGrp="1" noRot="1" noChangeAspect="1"/>
+          </p:cNvSpPr>
+          <p:nvPr>
+            <p:ph type="sldImg"/>
+          </p:nvPr>
+        </p:nvSpPr>
+        <p:spPr/>
+      </p:sp>
+      <p:sp>
+        <p:nvSpPr>
+          <p:cNvPr id="3" name="Notes Placeholder 2"/>
+          <p:cNvSpPr>
+            <a:spLocks noGrp="1"/>
+          </p:cNvSpPr>
+          <p:nvPr>
+            <p:ph type="body" idx="1"/>
+          </p:nvPr>
+        </p:nvSpPr>
+        <p:spPr/>
+        <p:txBody>
+          <a:bodyPr/>
+          <a:lstStyle/>
+          <a:p>
+            <a:r>
+              <a:rPr lang="en-US" dirty="0"/>
+              <a:t/>
+            </a:r>
+            <a:endParaRPr lang="en-US" dirty="0"/>
+          </a:p>
+        </p:txBody>
+      </p:sp>
+      <p:sp>
+        <p:nvSpPr>
+          <p:cNvPr id="4" name="Slide Number Placeholder 3"/>
+          <p:cNvSpPr>
+            <a:spLocks noGrp="1"/>
+          </p:cNvSpPr>
+          <p:nvPr>
+            <p:ph type="sldNum" sz="quarter" idx="10"/>
+          </p:nvPr>
+        </p:nvSpPr>
+        <p:spPr/>
+        <p:txBody>
+          <a:bodyPr/>
+          <a:lstStyle/>
+          <a:p>
+            <a:fld id="{F7021451-1387-4CA6-816F-3879F97B5CBC}" type="slidenum">
+              <a:rPr lang="en-US"/>
+              <a:t>14</a:t>
+            </a:fld>
+            <a:endParaRPr lang="en-US"/>
+          </a:p>
+        </p:txBody>
+      </p:sp>
+    </p:spTree>
+    <p:extLst>
+      <p:ext uri="{BB962C8B-B14F-4D97-AF65-F5344CB8AC3E}">
+        <p14:creationId xmlns:p14="http://schemas.microsoft.com/office/powerpoint/2010/main" val="1024086991"/>
+      </p:ext>
+    </p:extLst>
+  </p:cSld>
+  <p:clrMapOvr>
+    <a:masterClrMapping/>
+  </p:clrMapOvr>
+</p:notes>
+</file>
+
+<file path=ppt/notesSlides/notesSlide15.xml><?xml version="1.0" encoding="utf-8"?>
+<p:notes xmlns:a="http://schemas.openxmlformats.org/drawingml/2006/main" xmlns:r="http://schemas.openxmlformats.org/officeDocument/2006/relationships" xmlns:p="http://schemas.openxmlformats.org/presentationml/2006/main">
+  <p:cSld>
+    <p:spTree>
+      <p:nvGrpSpPr>
+        <p:cNvPr id="1" name=""/>
+        <p:cNvGrpSpPr/>
+        <p:nvPr/>
+      </p:nvGrpSpPr>
+      <p:grpSpPr>
+        <a:xfrm>
+          <a:off x="0" y="0"/>
+          <a:ext cx="0" cy="0"/>
+          <a:chOff x="0" y="0"/>
+          <a:chExt cx="0" cy="0"/>
+        </a:xfrm>
+      </p:grpSpPr>
+      <p:sp>
+        <p:nvSpPr>
+          <p:cNvPr id="2" name="Slide Image Placeholder 1"/>
+          <p:cNvSpPr>
+            <a:spLocks noGrp="1" noRot="1" noChangeAspect="1"/>
+          </p:cNvSpPr>
+          <p:nvPr>
+            <p:ph type="sldImg"/>
+          </p:nvPr>
+        </p:nvSpPr>
+        <p:spPr/>
+      </p:sp>
+      <p:sp>
+        <p:nvSpPr>
+          <p:cNvPr id="3" name="Notes Placeholder 2"/>
+          <p:cNvSpPr>
+            <a:spLocks noGrp="1"/>
+          </p:cNvSpPr>
+          <p:nvPr>
+            <p:ph type="body" idx="1"/>
+          </p:nvPr>
+        </p:nvSpPr>
+        <p:spPr/>
+        <p:txBody>
+          <a:bodyPr/>
+          <a:lstStyle/>
+          <a:p>
+            <a:r>
+              <a:rPr lang="en-US" dirty="0"/>
+              <a:t/>
+            </a:r>
+            <a:endParaRPr lang="en-US" dirty="0"/>
+          </a:p>
+        </p:txBody>
+      </p:sp>
+      <p:sp>
+        <p:nvSpPr>
+          <p:cNvPr id="4" name="Slide Number Placeholder 3"/>
+          <p:cNvSpPr>
+            <a:spLocks noGrp="1"/>
+          </p:cNvSpPr>
+          <p:nvPr>
+            <p:ph type="sldNum" sz="quarter" idx="10"/>
+          </p:nvPr>
+        </p:nvSpPr>
+        <p:spPr/>
+        <p:txBody>
+          <a:bodyPr/>
+          <a:lstStyle/>
+          <a:p>
+            <a:fld id="{F7021451-1387-4CA6-816F-3879F97B5CBC}" type="slidenum">
+              <a:rPr lang="en-US"/>
+              <a:t>15</a:t>
+            </a:fld>
+            <a:endParaRPr lang="en-US"/>
+          </a:p>
+        </p:txBody>
+      </p:sp>
+    </p:spTree>
+    <p:extLst>
+      <p:ext uri="{BB962C8B-B14F-4D97-AF65-F5344CB8AC3E}">
+        <p14:creationId xmlns:p14="http://schemas.microsoft.com/office/powerpoint/2010/main" val="1024086991"/>
+      </p:ext>
+    </p:extLst>
+  </p:cSld>
+  <p:clrMapOvr>
+    <a:masterClrMapping/>
+  </p:clrMapOvr>
+</p:notes>
+</file>
+
+<file path=ppt/notesSlides/notesSlide16.xml><?xml version="1.0" encoding="utf-8"?>
+<p:notes xmlns:a="http://schemas.openxmlformats.org/drawingml/2006/main" xmlns:r="http://schemas.openxmlformats.org/officeDocument/2006/relationships" xmlns:p="http://schemas.openxmlformats.org/presentationml/2006/main">
+  <p:cSld>
+    <p:spTree>
+      <p:nvGrpSpPr>
+        <p:cNvPr id="1" name=""/>
+        <p:cNvGrpSpPr/>
+        <p:nvPr/>
+      </p:nvGrpSpPr>
+      <p:grpSpPr>
+        <a:xfrm>
+          <a:off x="0" y="0"/>
+          <a:ext cx="0" cy="0"/>
+          <a:chOff x="0" y="0"/>
+          <a:chExt cx="0" cy="0"/>
+        </a:xfrm>
+      </p:grpSpPr>
+      <p:sp>
+        <p:nvSpPr>
+          <p:cNvPr id="2" name="Slide Image Placeholder 1"/>
+          <p:cNvSpPr>
+            <a:spLocks noGrp="1" noRot="1" noChangeAspect="1"/>
+          </p:cNvSpPr>
+          <p:nvPr>
+            <p:ph type="sldImg"/>
+          </p:nvPr>
+        </p:nvSpPr>
+        <p:spPr/>
+      </p:sp>
+      <p:sp>
+        <p:nvSpPr>
+          <p:cNvPr id="3" name="Notes Placeholder 2"/>
+          <p:cNvSpPr>
+            <a:spLocks noGrp="1"/>
+          </p:cNvSpPr>
+          <p:nvPr>
+            <p:ph type="body" idx="1"/>
+          </p:nvPr>
+        </p:nvSpPr>
+        <p:spPr/>
+        <p:txBody>
+          <a:bodyPr/>
+          <a:lstStyle/>
+          <a:p>
+            <a:r>
+              <a:rPr lang="en-US" dirty="0"/>
+              <a:t/>
+            </a:r>
+            <a:endParaRPr lang="en-US" dirty="0"/>
+          </a:p>
+        </p:txBody>
+      </p:sp>
+      <p:sp>
+        <p:nvSpPr>
+          <p:cNvPr id="4" name="Slide Number Placeholder 3"/>
+          <p:cNvSpPr>
+            <a:spLocks noGrp="1"/>
+          </p:cNvSpPr>
+          <p:nvPr>
+            <p:ph type="sldNum" sz="quarter" idx="10"/>
+          </p:nvPr>
+        </p:nvSpPr>
+        <p:spPr/>
+        <p:txBody>
+          <a:bodyPr/>
+          <a:lstStyle/>
+          <a:p>
+            <a:fld id="{F7021451-1387-4CA6-816F-3879F97B5CBC}" type="slidenum">
+              <a:rPr lang="en-US"/>
+              <a:t>16</a:t>
             </a:fld>
             <a:endParaRPr lang="en-US"/>
           </a:p>
@@ -2117,7 +2384,7 @@
                 <a:ea typeface="Calibri" pitchFamily="34" charset="-122"/>
                 <a:cs typeface="Calibri" pitchFamily="34" charset="-120"/>
               </a:rPr>
-              <a:t>versão 3.46.0 · 2026-09-08</a:t>
+              <a:t>versão 3.48.0 · 2026-09-08</a:t>
             </a:r>
             <a:endParaRPr lang="en-US" sz="1200" dirty="0"/>
           </a:p>
@@ -2599,7 +2866,7 @@
                 <a:ea typeface="Calibri" pitchFamily="34" charset="-122"/>
                 <a:cs typeface="Calibri" pitchFamily="34" charset="-120"/>
               </a:rPr>
-              <a:t>WX Claude Code 3.46.0 · Built to convert. Engineered to prove.</a:t>
+              <a:t>WX Claude Code 3.48.0 · Built to convert. Engineered to prove.</a:t>
             </a:r>
             <a:endParaRPr lang="en-US" sz="1000" dirty="0"/>
           </a:p>
@@ -3163,7 +3430,7 @@
                 <a:ea typeface="Calibri" pitchFamily="34" charset="-122"/>
                 <a:cs typeface="Calibri" pitchFamily="34" charset="-120"/>
               </a:rPr>
-              <a:t>WX Claude Code 3.46.0 · Built to convert. Engineered to prove.</a:t>
+              <a:t>WX Claude Code 3.48.0 · Built to convert. Engineered to prove.</a:t>
             </a:r>
             <a:endParaRPr lang="en-US" sz="1000" dirty="0"/>
           </a:p>
@@ -3180,6 +3447,536 @@
 <file path=ppt/slides/slide12.xml><?xml version="1.0" encoding="utf-8"?>
 <p:sld xmlns:a="http://schemas.openxmlformats.org/drawingml/2006/main" xmlns:r="http://schemas.openxmlformats.org/officeDocument/2006/relationships" xmlns:p="http://schemas.openxmlformats.org/presentationml/2006/main">
   <p:cSld name="Slide 12">
+    <p:bg>
+      <p:bgPr>
+        <a:solidFill>
+          <a:srgbClr val="010418"/>
+        </a:solidFill>
+      </p:bgPr>
+    </p:bg>
+    <p:spTree>
+      <p:nvGrpSpPr>
+        <p:cNvPr id="1" name=""/>
+        <p:cNvGrpSpPr/>
+        <p:nvPr/>
+      </p:nvGrpSpPr>
+      <p:grpSpPr>
+        <a:xfrm>
+          <a:off x="0" y="0"/>
+          <a:ext cx="0" cy="0"/>
+          <a:chOff x="0" y="0"/>
+          <a:chExt cx="0" cy="0"/>
+        </a:xfrm>
+      </p:grpSpPr>
+      <p:sp>
+        <p:nvSpPr>
+          <p:cNvPr id="2" name="Text 0"/>
+          <p:cNvSpPr txBox="1"/>
+          <p:nvPr/>
+        </p:nvSpPr>
+        <p:spPr>
+          <a:xfrm>
+            <a:off x="548640" y="411480"/>
+            <a:ext cx="11064240" cy="822960"/>
+          </a:xfrm>
+          <a:prstGeom prst="rect">
+            <a:avLst/>
+          </a:prstGeom>
+          <a:noFill/>
+          <a:ln/>
+        </p:spPr>
+        <p:txBody>
+          <a:bodyPr wrap="square" lIns="0" tIns="0" rIns="0" bIns="0" rtlCol="0" anchor="ctr"/>
+          <a:lstStyle/>
+          <a:p>
+            <a:pPr indent="0" marL="0">
+              <a:buNone/>
+            </a:pPr>
+            <a:r>
+              <a:rPr lang="en-US" sz="3400" b="1" dirty="0">
+                <a:solidFill>
+                  <a:srgbClr val="FFFFFF"/>
+                </a:solidFill>
+                <a:latin typeface="Century Schoolbook" pitchFamily="34" charset="0"/>
+                <a:ea typeface="Century Schoolbook" pitchFamily="34" charset="-122"/>
+                <a:cs typeface="Century Schoolbook" pitchFamily="34" charset="-120"/>
+              </a:rPr>
+              <a:t>Por que comprar: a prova</a:t>
+            </a:r>
+            <a:endParaRPr lang="en-US" sz="3400" dirty="0"/>
+          </a:p>
+        </p:txBody>
+      </p:sp>
+      <p:sp>
+        <p:nvSpPr>
+          <p:cNvPr id="3" name="Shape 1"/>
+          <p:cNvSpPr/>
+          <p:nvPr/>
+        </p:nvSpPr>
+        <p:spPr>
+          <a:xfrm>
+            <a:off x="548640" y="1417320"/>
+            <a:ext cx="5394960" cy="2103120"/>
+          </a:xfrm>
+          <a:prstGeom prst="roundRect">
+            <a:avLst>
+              <a:gd name="adj" fmla="val 6522"/>
+            </a:avLst>
+          </a:prstGeom>
+          <a:solidFill>
+            <a:srgbClr val="121527"/>
+          </a:solidFill>
+          <a:ln w="12700">
+            <a:solidFill>
+              <a:srgbClr val="2E3454"/>
+            </a:solidFill>
+            <a:prstDash val="solid"/>
+          </a:ln>
+        </p:spPr>
+      </p:sp>
+      <p:sp>
+        <p:nvSpPr>
+          <p:cNvPr id="4" name="Text 2"/>
+          <p:cNvSpPr txBox="1"/>
+          <p:nvPr/>
+        </p:nvSpPr>
+        <p:spPr>
+          <a:xfrm>
+            <a:off x="822960" y="1618488"/>
+            <a:ext cx="4846320" cy="548640"/>
+          </a:xfrm>
+          <a:prstGeom prst="rect">
+            <a:avLst/>
+          </a:prstGeom>
+          <a:noFill/>
+          <a:ln/>
+        </p:spPr>
+        <p:txBody>
+          <a:bodyPr wrap="square" lIns="0" tIns="0" rIns="0" bIns="0" rtlCol="0" anchor="t"/>
+          <a:lstStyle/>
+          <a:p>
+            <a:pPr indent="0" marL="0">
+              <a:buNone/>
+            </a:pPr>
+            <a:r>
+              <a:rPr lang="en-US" sz="1800" b="1" dirty="0">
+                <a:solidFill>
+                  <a:srgbClr val="F7B733"/>
+                </a:solidFill>
+                <a:latin typeface="Century Schoolbook" pitchFamily="34" charset="0"/>
+                <a:ea typeface="Century Schoolbook" pitchFamily="34" charset="-122"/>
+                <a:cs typeface="Century Schoolbook" pitchFamily="34" charset="-120"/>
+              </a:rPr>
+              <a:t>O que você compra é a prova</a:t>
+            </a:r>
+            <a:endParaRPr lang="en-US" sz="1800" dirty="0"/>
+          </a:p>
+        </p:txBody>
+      </p:sp>
+      <p:sp>
+        <p:nvSpPr>
+          <p:cNvPr id="5" name="Text 3"/>
+          <p:cNvSpPr txBox="1"/>
+          <p:nvPr/>
+        </p:nvSpPr>
+        <p:spPr>
+          <a:xfrm>
+            <a:off x="822960" y="2194560"/>
+            <a:ext cx="4846320" cy="1234440"/>
+          </a:xfrm>
+          <a:prstGeom prst="rect">
+            <a:avLst/>
+          </a:prstGeom>
+          <a:noFill/>
+          <a:ln/>
+        </p:spPr>
+        <p:txBody>
+          <a:bodyPr wrap="square" lIns="0" tIns="0" rIns="0" bIns="0" rtlCol="0" anchor="t"/>
+          <a:lstStyle/>
+          <a:p>
+            <a:pPr indent="0" marL="0">
+              <a:buNone/>
+            </a:pPr>
+            <a:r>
+              <a:rPr lang="en-US" sz="1300" dirty="0">
+                <a:solidFill>
+                  <a:srgbClr val="EDEDF3"/>
+                </a:solidFill>
+                <a:latin typeface="Calibri" pitchFamily="34" charset="0"/>
+                <a:ea typeface="Calibri" pitchFamily="34" charset="-122"/>
+                <a:cs typeface="Calibri" pitchFamily="34" charset="-120"/>
+              </a:rPr>
+              <a:t>Qualquer sessão converte uma procedure em minutos. O que ela não faz sozinha é dizer se a regra ficou igual. O plugin captura o golden master do legado rodando, compara e devolve um número.</a:t>
+            </a:r>
+            <a:endParaRPr lang="en-US" sz="1300" dirty="0"/>
+          </a:p>
+        </p:txBody>
+      </p:sp>
+      <p:sp>
+        <p:nvSpPr>
+          <p:cNvPr id="6" name="Shape 4"/>
+          <p:cNvSpPr/>
+          <p:nvPr/>
+        </p:nvSpPr>
+        <p:spPr>
+          <a:xfrm>
+            <a:off x="6217920" y="1417320"/>
+            <a:ext cx="5394960" cy="2103120"/>
+          </a:xfrm>
+          <a:prstGeom prst="roundRect">
+            <a:avLst>
+              <a:gd name="adj" fmla="val 6522"/>
+            </a:avLst>
+          </a:prstGeom>
+          <a:solidFill>
+            <a:srgbClr val="121527"/>
+          </a:solidFill>
+          <a:ln w="12700">
+            <a:solidFill>
+              <a:srgbClr val="2E3454"/>
+            </a:solidFill>
+            <a:prstDash val="solid"/>
+          </a:ln>
+        </p:spPr>
+      </p:sp>
+      <p:sp>
+        <p:nvSpPr>
+          <p:cNvPr id="7" name="Text 5"/>
+          <p:cNvSpPr txBox="1"/>
+          <p:nvPr/>
+        </p:nvSpPr>
+        <p:spPr>
+          <a:xfrm>
+            <a:off x="6492240" y="1618488"/>
+            <a:ext cx="4846320" cy="548640"/>
+          </a:xfrm>
+          <a:prstGeom prst="rect">
+            <a:avLst/>
+          </a:prstGeom>
+          <a:noFill/>
+          <a:ln/>
+        </p:spPr>
+        <p:txBody>
+          <a:bodyPr wrap="square" lIns="0" tIns="0" rIns="0" bIns="0" rtlCol="0" anchor="t"/>
+          <a:lstStyle/>
+          <a:p>
+            <a:pPr indent="0" marL="0">
+              <a:buNone/>
+            </a:pPr>
+            <a:r>
+              <a:rPr lang="en-US" sz="1800" b="1" dirty="0">
+                <a:solidFill>
+                  <a:srgbClr val="F7B733"/>
+                </a:solidFill>
+                <a:latin typeface="Century Schoolbook" pitchFamily="34" charset="0"/>
+                <a:ea typeface="Century Schoolbook" pitchFamily="34" charset="-122"/>
+                <a:cs typeface="Century Schoolbook" pitchFamily="34" charset="-120"/>
+              </a:rPr>
+              <a:t>Impede o erro mais caro: inventar</a:t>
+            </a:r>
+            <a:endParaRPr lang="en-US" sz="1800" dirty="0"/>
+          </a:p>
+        </p:txBody>
+      </p:sp>
+      <p:sp>
+        <p:nvSpPr>
+          <p:cNvPr id="8" name="Text 6"/>
+          <p:cNvSpPr txBox="1"/>
+          <p:nvPr/>
+        </p:nvSpPr>
+        <p:spPr>
+          <a:xfrm>
+            <a:off x="6492240" y="2194560"/>
+            <a:ext cx="4846320" cy="1234440"/>
+          </a:xfrm>
+          <a:prstGeom prst="rect">
+            <a:avLst/>
+          </a:prstGeom>
+          <a:noFill/>
+          <a:ln/>
+        </p:spPr>
+        <p:txBody>
+          <a:bodyPr wrap="square" lIns="0" tIns="0" rIns="0" bIns="0" rtlCol="0" anchor="t"/>
+          <a:lstStyle/>
+          <a:p>
+            <a:pPr indent="0" marL="0">
+              <a:buNone/>
+            </a:pPr>
+            <a:r>
+              <a:rPr lang="en-US" sz="1300" dirty="0">
+                <a:solidFill>
+                  <a:srgbClr val="EDEDF3"/>
+                </a:solidFill>
+                <a:latin typeface="Calibri" pitchFamily="34" charset="0"/>
+                <a:ea typeface="Calibri" pitchFamily="34" charset="-122"/>
+                <a:cs typeface="Calibri" pitchFamily="34" charset="-120"/>
+              </a:rPr>
+              <a:t>Se o PDF não diz como a procedure funciona, vira lacuna escrita e linha bloqueada. Não completa por conta própria. O exemplo WINDEV tem uma lacuna plantada, e o grafo a acusa até hoje.</a:t>
+            </a:r>
+            <a:endParaRPr lang="en-US" sz="1300" dirty="0"/>
+          </a:p>
+        </p:txBody>
+      </p:sp>
+      <p:sp>
+        <p:nvSpPr>
+          <p:cNvPr id="9" name="Shape 7"/>
+          <p:cNvSpPr/>
+          <p:nvPr/>
+        </p:nvSpPr>
+        <p:spPr>
+          <a:xfrm>
+            <a:off x="548640" y="3749040"/>
+            <a:ext cx="5394960" cy="2103120"/>
+          </a:xfrm>
+          <a:prstGeom prst="roundRect">
+            <a:avLst>
+              <a:gd name="adj" fmla="val 6522"/>
+            </a:avLst>
+          </a:prstGeom>
+          <a:solidFill>
+            <a:srgbClr val="121527"/>
+          </a:solidFill>
+          <a:ln w="12700">
+            <a:solidFill>
+              <a:srgbClr val="2E3454"/>
+            </a:solidFill>
+            <a:prstDash val="solid"/>
+          </a:ln>
+        </p:spPr>
+      </p:sp>
+      <p:sp>
+        <p:nvSpPr>
+          <p:cNvPr id="10" name="Text 8"/>
+          <p:cNvSpPr txBox="1"/>
+          <p:nvPr/>
+        </p:nvSpPr>
+        <p:spPr>
+          <a:xfrm>
+            <a:off x="822960" y="3950208"/>
+            <a:ext cx="4846320" cy="548640"/>
+          </a:xfrm>
+          <a:prstGeom prst="rect">
+            <a:avLst/>
+          </a:prstGeom>
+          <a:noFill/>
+          <a:ln/>
+        </p:spPr>
+        <p:txBody>
+          <a:bodyPr wrap="square" lIns="0" tIns="0" rIns="0" bIns="0" rtlCol="0" anchor="t"/>
+          <a:lstStyle/>
+          <a:p>
+            <a:pPr indent="0" marL="0">
+              <a:buNone/>
+            </a:pPr>
+            <a:r>
+              <a:rPr lang="en-US" sz="1800" b="1" dirty="0">
+                <a:solidFill>
+                  <a:srgbClr val="F7B733"/>
+                </a:solidFill>
+                <a:latin typeface="Century Schoolbook" pitchFamily="34" charset="0"/>
+                <a:ea typeface="Century Schoolbook" pitchFamily="34" charset="-122"/>
+                <a:cs typeface="Century Schoolbook" pitchFamily="34" charset="-120"/>
+              </a:rPr>
+              <a:t>Sessões não esquecem mais</a:t>
+            </a:r>
+            <a:endParaRPr lang="en-US" sz="1800" dirty="0"/>
+          </a:p>
+        </p:txBody>
+      </p:sp>
+      <p:sp>
+        <p:nvSpPr>
+          <p:cNvPr id="11" name="Text 9"/>
+          <p:cNvSpPr txBox="1"/>
+          <p:nvPr/>
+        </p:nvSpPr>
+        <p:spPr>
+          <a:xfrm>
+            <a:off x="822960" y="4526280"/>
+            <a:ext cx="4846320" cy="1234440"/>
+          </a:xfrm>
+          <a:prstGeom prst="rect">
+            <a:avLst/>
+          </a:prstGeom>
+          <a:noFill/>
+          <a:ln/>
+        </p:spPr>
+        <p:txBody>
+          <a:bodyPr wrap="square" lIns="0" tIns="0" rIns="0" bIns="0" rtlCol="0" anchor="t"/>
+          <a:lstStyle/>
+          <a:p>
+            <a:pPr indent="0" marL="0">
+              <a:buNone/>
+            </a:pPr>
+            <a:r>
+              <a:rPr lang="en-US" sz="1300" dirty="0">
+                <a:solidFill>
+                  <a:srgbClr val="EDEDF3"/>
+                </a:solidFill>
+                <a:latin typeface="Calibri" pitchFamily="34" charset="0"/>
+                <a:ea typeface="Calibri" pitchFamily="34" charset="-122"/>
+                <a:cs typeface="Calibri" pitchFamily="34" charset="-120"/>
+              </a:rPr>
+              <a:t>O questionário vira o contexto que toda sessão lê antes do primeiro comando. O contrato ativo diz o que vale hoje, com hash. Decisões guardam a base delas.</a:t>
+            </a:r>
+            <a:endParaRPr lang="en-US" sz="1300" dirty="0"/>
+          </a:p>
+        </p:txBody>
+      </p:sp>
+      <p:sp>
+        <p:nvSpPr>
+          <p:cNvPr id="12" name="Shape 10"/>
+          <p:cNvSpPr/>
+          <p:nvPr/>
+        </p:nvSpPr>
+        <p:spPr>
+          <a:xfrm>
+            <a:off x="6217920" y="3749040"/>
+            <a:ext cx="5394960" cy="2103120"/>
+          </a:xfrm>
+          <a:prstGeom prst="roundRect">
+            <a:avLst>
+              <a:gd name="adj" fmla="val 6522"/>
+            </a:avLst>
+          </a:prstGeom>
+          <a:solidFill>
+            <a:srgbClr val="121527"/>
+          </a:solidFill>
+          <a:ln w="12700">
+            <a:solidFill>
+              <a:srgbClr val="2E3454"/>
+            </a:solidFill>
+            <a:prstDash val="solid"/>
+          </a:ln>
+        </p:spPr>
+      </p:sp>
+      <p:sp>
+        <p:nvSpPr>
+          <p:cNvPr id="13" name="Text 11"/>
+          <p:cNvSpPr txBox="1"/>
+          <p:nvPr/>
+        </p:nvSpPr>
+        <p:spPr>
+          <a:xfrm>
+            <a:off x="6492240" y="3950208"/>
+            <a:ext cx="4846320" cy="548640"/>
+          </a:xfrm>
+          <a:prstGeom prst="rect">
+            <a:avLst/>
+          </a:prstGeom>
+          <a:noFill/>
+          <a:ln/>
+        </p:spPr>
+        <p:txBody>
+          <a:bodyPr wrap="square" lIns="0" tIns="0" rIns="0" bIns="0" rtlCol="0" anchor="t"/>
+          <a:lstStyle/>
+          <a:p>
+            <a:pPr indent="0" marL="0">
+              <a:buNone/>
+            </a:pPr>
+            <a:r>
+              <a:rPr lang="en-US" sz="1800" b="1" dirty="0">
+                <a:solidFill>
+                  <a:srgbClr val="F7B733"/>
+                </a:solidFill>
+                <a:latin typeface="Century Schoolbook" pitchFamily="34" charset="0"/>
+                <a:ea typeface="Century Schoolbook" pitchFamily="34" charset="-122"/>
+                <a:cs typeface="Century Schoolbook" pitchFamily="34" charset="-120"/>
+              </a:rPr>
+              <a:t>Quem escreve não valida</a:t>
+            </a:r>
+            <a:endParaRPr lang="en-US" sz="1800" dirty="0"/>
+          </a:p>
+        </p:txBody>
+      </p:sp>
+      <p:sp>
+        <p:nvSpPr>
+          <p:cNvPr id="14" name="Text 12"/>
+          <p:cNvSpPr txBox="1"/>
+          <p:nvPr/>
+        </p:nvSpPr>
+        <p:spPr>
+          <a:xfrm>
+            <a:off x="6492240" y="4526280"/>
+            <a:ext cx="4846320" cy="1234440"/>
+          </a:xfrm>
+          <a:prstGeom prst="rect">
+            <a:avLst/>
+          </a:prstGeom>
+          <a:noFill/>
+          <a:ln/>
+        </p:spPr>
+        <p:txBody>
+          <a:bodyPr wrap="square" lIns="0" tIns="0" rIns="0" bIns="0" rtlCol="0" anchor="t"/>
+          <a:lstStyle/>
+          <a:p>
+            <a:pPr indent="0" marL="0">
+              <a:buNone/>
+            </a:pPr>
+            <a:r>
+              <a:rPr lang="en-US" sz="1300" dirty="0">
+                <a:solidFill>
+                  <a:srgbClr val="EDEDF3"/>
+                </a:solidFill>
+                <a:latin typeface="Calibri" pitchFamily="34" charset="0"/>
+                <a:ea typeface="Calibri" pitchFamily="34" charset="-122"/>
+                <a:cs typeface="Calibri" pitchFamily="34" charset="-120"/>
+              </a:rPr>
+              <a:t>O G0 nega escrita enquanto as evidências não estão em ordem. Dois portões na saída perguntam se funciona e se está conforme. Quem valida entra com outro papel e não conserta o que detecta.</a:t>
+            </a:r>
+            <a:endParaRPr lang="en-US" sz="1300" dirty="0"/>
+          </a:p>
+        </p:txBody>
+      </p:sp>
+      <p:sp>
+        <p:nvSpPr>
+          <p:cNvPr id="15" name="Text 13"/>
+          <p:cNvSpPr txBox="1"/>
+          <p:nvPr/>
+        </p:nvSpPr>
+        <p:spPr>
+          <a:xfrm>
+            <a:off x="548640" y="6400800"/>
+            <a:ext cx="8229600" cy="274320"/>
+          </a:xfrm>
+          <a:prstGeom prst="rect">
+            <a:avLst/>
+          </a:prstGeom>
+          <a:noFill/>
+          <a:ln/>
+        </p:spPr>
+        <p:txBody>
+          <a:bodyPr wrap="square" lIns="0" tIns="0" rIns="0" bIns="0" rtlCol="0" anchor="ctr"/>
+          <a:lstStyle/>
+          <a:p>
+            <a:pPr indent="0" marL="0">
+              <a:buNone/>
+            </a:pPr>
+            <a:r>
+              <a:rPr lang="en-US" sz="1000" dirty="0">
+                <a:solidFill>
+                  <a:srgbClr val="9AA0B8"/>
+                </a:solidFill>
+                <a:latin typeface="Calibri" pitchFamily="34" charset="0"/>
+                <a:ea typeface="Calibri" pitchFamily="34" charset="-122"/>
+                <a:cs typeface="Calibri" pitchFamily="34" charset="-120"/>
+              </a:rPr>
+              <a:t>WX Claude Code 3.48.0 · Built to convert. Engineered to prove.</a:t>
+            </a:r>
+            <a:endParaRPr lang="en-US" sz="1000" dirty="0"/>
+          </a:p>
+        </p:txBody>
+      </p:sp>
+    </p:spTree>
+  </p:cSld>
+  <p:clrMapOvr>
+    <a:masterClrMapping/>
+  </p:clrMapOvr>
+</p:sld>
+</file>
+
+<file path=ppt/slides/slide13.xml><?xml version="1.0" encoding="utf-8"?>
+<p:sld xmlns:a="http://schemas.openxmlformats.org/drawingml/2006/main" xmlns:r="http://schemas.openxmlformats.org/officeDocument/2006/relationships" xmlns:p="http://schemas.openxmlformats.org/presentationml/2006/main">
+  <p:cSld name="Slide 13">
     <p:bg>
       <p:bgPr>
         <a:solidFill>
@@ -3234,7 +4031,7 @@
                 <a:ea typeface="Century Schoolbook" pitchFamily="34" charset="-122"/>
                 <a:cs typeface="Century Schoolbook" pitchFamily="34" charset="-120"/>
               </a:rPr>
-              <a:t>Como começar: quatro passos</a:t>
+              <a:t>Por que comprar: o resto do argumento</a:t>
             </a:r>
             <a:endParaRPr lang="en-US" sz="3400" dirty="0"/>
           </a:p>
@@ -3248,12 +4045,12 @@
         </p:nvSpPr>
         <p:spPr>
           <a:xfrm>
-            <a:off x="548640" y="1463040"/>
-            <a:ext cx="2651760" cy="4206240"/>
+            <a:off x="548640" y="1417320"/>
+            <a:ext cx="5394960" cy="2103120"/>
           </a:xfrm>
           <a:prstGeom prst="roundRect">
             <a:avLst>
-              <a:gd name="adj" fmla="val 4138"/>
+              <a:gd name="adj" fmla="val 6522"/>
             </a:avLst>
           </a:prstGeom>
           <a:solidFill>
@@ -3282,24 +4079,24 @@
         </p:nvSpPr>
         <p:spPr>
           <a:xfrm>
-            <a:off x="777240" y="1645920"/>
-            <a:ext cx="914400" cy="822960"/>
-          </a:xfrm>
-          <a:prstGeom prst="rect">
-            <a:avLst/>
-          </a:prstGeom>
-          <a:noFill/>
-          <a:ln/>
-        </p:spPr>
-        <p:txBody>
-          <a:bodyPr wrap="square" lIns="0" tIns="0" rIns="0" bIns="0" rtlCol="0" anchor="ctr"/>
-          <a:lstStyle/>
-          <a:p>
-            <a:pPr indent="0" marL="0">
-              <a:buNone/>
-            </a:pPr>
-            <a:r>
-              <a:rPr lang="en-US" sz="4400" b="1" dirty="0">
+            <a:off x="822960" y="1618488"/>
+            <a:ext cx="4846320" cy="548640"/>
+          </a:xfrm>
+          <a:prstGeom prst="rect">
+            <a:avLst/>
+          </a:prstGeom>
+          <a:noFill/>
+          <a:ln/>
+        </p:spPr>
+        <p:txBody>
+          <a:bodyPr wrap="square" lIns="0" tIns="0" rIns="0" bIns="0" rtlCol="0" anchor="t"/>
+          <a:lstStyle/>
+          <a:p>
+            <a:pPr indent="0" marL="0">
+              <a:buNone/>
+            </a:pPr>
+            <a:r>
+              <a:rPr lang="en-US" sz="1800" b="1" dirty="0">
                 <a:solidFill>
                   <a:srgbClr val="E2261C"/>
                 </a:solidFill>
@@ -3307,9 +4104,9 @@
                 <a:ea typeface="Century Schoolbook" pitchFamily="34" charset="-122"/>
                 <a:cs typeface="Century Schoolbook" pitchFamily="34" charset="-120"/>
               </a:rPr>
-              <a:t>1</a:t>
-            </a:r>
-            <a:endParaRPr lang="en-US" sz="4400" dirty="0"/>
+              <a:t>Sabe WLanguage de verdade</a:t>
+            </a:r>
+            <a:endParaRPr lang="en-US" sz="1800" dirty="0"/>
           </a:p>
         </p:txBody>
       </p:sp>
@@ -3321,95 +4118,17 @@
         </p:nvSpPr>
         <p:spPr>
           <a:xfrm>
-            <a:off x="777240" y="2514600"/>
-            <a:ext cx="2286000" cy="457200"/>
-          </a:xfrm>
-          <a:prstGeom prst="rect">
-            <a:avLst/>
-          </a:prstGeom>
-          <a:noFill/>
-          <a:ln/>
-        </p:spPr>
-        <p:txBody>
-          <a:bodyPr wrap="square" lIns="0" tIns="0" rIns="0" bIns="0" rtlCol="0" anchor="ctr"/>
-          <a:lstStyle/>
-          <a:p>
-            <a:pPr indent="0" marL="0">
-              <a:buNone/>
-            </a:pPr>
-            <a:r>
-              <a:rPr lang="en-US" sz="1800" b="1" dirty="0">
-                <a:solidFill>
-                  <a:srgbClr val="14161F"/>
-                </a:solidFill>
-                <a:latin typeface="Calibri" pitchFamily="34" charset="0"/>
-                <a:ea typeface="Calibri" pitchFamily="34" charset="-122"/>
-                <a:cs typeface="Calibri" pitchFamily="34" charset="-120"/>
-              </a:rPr>
-              <a:t>Instalar</a:t>
-            </a:r>
-            <a:endParaRPr lang="en-US" sz="1800" dirty="0"/>
-          </a:p>
-        </p:txBody>
-      </p:sp>
-      <p:sp>
-        <p:nvSpPr>
-          <p:cNvPr id="6" name="Text 4"/>
-          <p:cNvSpPr txBox="1"/>
-          <p:nvPr/>
-        </p:nvSpPr>
-        <p:spPr>
-          <a:xfrm>
-            <a:off x="777240" y="3017520"/>
-            <a:ext cx="2286000" cy="731520"/>
-          </a:xfrm>
-          <a:prstGeom prst="rect">
-            <a:avLst/>
-          </a:prstGeom>
-          <a:noFill/>
-          <a:ln/>
-        </p:spPr>
-        <p:txBody>
-          <a:bodyPr wrap="square" lIns="0" tIns="0" rIns="0" bIns="0" rtlCol="0" anchor="ctr"/>
-          <a:lstStyle/>
-          <a:p>
-            <a:pPr indent="0" marL="0">
-              <a:buNone/>
-            </a:pPr>
-            <a:r>
-              <a:rPr lang="en-US" sz="1100" dirty="0">
-                <a:solidFill>
-                  <a:srgbClr val="E2261C"/>
-                </a:solidFill>
-                <a:latin typeface="Courier New" pitchFamily="34" charset="0"/>
-                <a:ea typeface="Courier New" pitchFamily="34" charset="-122"/>
-                <a:cs typeface="Courier New" pitchFamily="34" charset="-120"/>
-              </a:rPr>
-              <a:t>./instalar.sh --serial … --corpus …</a:t>
-            </a:r>
-            <a:endParaRPr lang="en-US" sz="1100" dirty="0"/>
-          </a:p>
-        </p:txBody>
-      </p:sp>
-      <p:sp>
-        <p:nvSpPr>
-          <p:cNvPr id="7" name="Text 5"/>
-          <p:cNvSpPr txBox="1"/>
-          <p:nvPr/>
-        </p:nvSpPr>
-        <p:spPr>
-          <a:xfrm>
-            <a:off x="777240" y="3840480"/>
-            <a:ext cx="2286000" cy="1645920"/>
-          </a:xfrm>
-          <a:prstGeom prst="rect">
-            <a:avLst/>
-          </a:prstGeom>
-          <a:noFill/>
-          <a:ln/>
-        </p:spPr>
-        <p:txBody>
-          <a:bodyPr wrap="square" lIns="0" tIns="0" rIns="0" bIns="0" rtlCol="0" anchor="ctr"/>
+            <a:off x="822960" y="2194560"/>
+            <a:ext cx="4846320" cy="1234440"/>
+          </a:xfrm>
+          <a:prstGeom prst="rect">
+            <a:avLst/>
+          </a:prstGeom>
+          <a:noFill/>
+          <a:ln/>
+        </p:spPr>
+        <p:txBody>
+          <a:bodyPr wrap="square" lIns="0" tIns="0" rIns="0" bIns="0" rtlCol="0" anchor="t"/>
           <a:lstStyle/>
           <a:p>
             <a:pPr indent="0" marL="0">
@@ -3424,7 +4143,7 @@
                 <a:ea typeface="Calibri" pitchFamily="34" charset="-122"/>
                 <a:cs typeface="Calibri" pitchFamily="34" charset="-120"/>
               </a:rPr>
-              <a:t>Uma vez por máquina. Aceita a licença, confere o corpus, instala no Claude Code.</a:t>
+              <a:t>7 especialistas por tema sobre 12.035 páginas do Help, e um runtime em Rust que faz o Round e a comparação de strings como o WINDEV. Saiu de ler o Help, não da memória do modelo.</a:t>
             </a:r>
             <a:endParaRPr lang="en-US" sz="1300" dirty="0"/>
           </a:p>
@@ -3432,18 +4151,18 @@
       </p:sp>
       <p:sp>
         <p:nvSpPr>
-          <p:cNvPr id="8" name="Shape 6"/>
+          <p:cNvPr id="6" name="Shape 4"/>
           <p:cNvSpPr/>
           <p:nvPr/>
         </p:nvSpPr>
         <p:spPr>
           <a:xfrm>
-            <a:off x="3383280" y="1463040"/>
-            <a:ext cx="2651760" cy="4206240"/>
+            <a:off x="6217920" y="1417320"/>
+            <a:ext cx="5394960" cy="2103120"/>
           </a:xfrm>
           <a:prstGeom prst="roundRect">
             <a:avLst>
-              <a:gd name="adj" fmla="val 4138"/>
+              <a:gd name="adj" fmla="val 6522"/>
             </a:avLst>
           </a:prstGeom>
           <a:solidFill>
@@ -3466,30 +4185,30 @@
       </p:sp>
       <p:sp>
         <p:nvSpPr>
-          <p:cNvPr id="9" name="Text 7"/>
-          <p:cNvSpPr txBox="1"/>
-          <p:nvPr/>
-        </p:nvSpPr>
-        <p:spPr>
-          <a:xfrm>
-            <a:off x="3611880" y="1645920"/>
-            <a:ext cx="914400" cy="822960"/>
-          </a:xfrm>
-          <a:prstGeom prst="rect">
-            <a:avLst/>
-          </a:prstGeom>
-          <a:noFill/>
-          <a:ln/>
-        </p:spPr>
-        <p:txBody>
-          <a:bodyPr wrap="square" lIns="0" tIns="0" rIns="0" bIns="0" rtlCol="0" anchor="ctr"/>
-          <a:lstStyle/>
-          <a:p>
-            <a:pPr indent="0" marL="0">
-              <a:buNone/>
-            </a:pPr>
-            <a:r>
-              <a:rPr lang="en-US" sz="4400" b="1" dirty="0">
+          <p:cNvPr id="7" name="Text 5"/>
+          <p:cNvSpPr txBox="1"/>
+          <p:nvPr/>
+        </p:nvSpPr>
+        <p:spPr>
+          <a:xfrm>
+            <a:off x="6492240" y="1618488"/>
+            <a:ext cx="4846320" cy="548640"/>
+          </a:xfrm>
+          <a:prstGeom prst="rect">
+            <a:avLst/>
+          </a:prstGeom>
+          <a:noFill/>
+          <a:ln/>
+        </p:spPr>
+        <p:txBody>
+          <a:bodyPr wrap="square" lIns="0" tIns="0" rIns="0" bIns="0" rtlCol="0" anchor="t"/>
+          <a:lstStyle/>
+          <a:p>
+            <a:pPr indent="0" marL="0">
+              <a:buNone/>
+            </a:pPr>
+            <a:r>
+              <a:rPr lang="en-US" sz="1800" b="1" dirty="0">
                 <a:solidFill>
                   <a:srgbClr val="E2261C"/>
                 </a:solidFill>
@@ -3497,46 +4216,7 @@
                 <a:ea typeface="Century Schoolbook" pitchFamily="34" charset="-122"/>
                 <a:cs typeface="Century Schoolbook" pitchFamily="34" charset="-120"/>
               </a:rPr>
-              <a:t>2</a:t>
-            </a:r>
-            <a:endParaRPr lang="en-US" sz="4400" dirty="0"/>
-          </a:p>
-        </p:txBody>
-      </p:sp>
-      <p:sp>
-        <p:nvSpPr>
-          <p:cNvPr id="10" name="Text 8"/>
-          <p:cNvSpPr txBox="1"/>
-          <p:nvPr/>
-        </p:nvSpPr>
-        <p:spPr>
-          <a:xfrm>
-            <a:off x="3611880" y="2514600"/>
-            <a:ext cx="2286000" cy="457200"/>
-          </a:xfrm>
-          <a:prstGeom prst="rect">
-            <a:avLst/>
-          </a:prstGeom>
-          <a:noFill/>
-          <a:ln/>
-        </p:spPr>
-        <p:txBody>
-          <a:bodyPr wrap="square" lIns="0" tIns="0" rIns="0" bIns="0" rtlCol="0" anchor="ctr"/>
-          <a:lstStyle/>
-          <a:p>
-            <a:pPr indent="0" marL="0">
-              <a:buNone/>
-            </a:pPr>
-            <a:r>
-              <a:rPr lang="en-US" sz="1800" b="1" dirty="0">
-                <a:solidFill>
-                  <a:srgbClr val="14161F"/>
-                </a:solidFill>
-                <a:latin typeface="Calibri" pitchFamily="34" charset="0"/>
-                <a:ea typeface="Calibri" pitchFamily="34" charset="-122"/>
-                <a:cs typeface="Calibri" pitchFamily="34" charset="-120"/>
-              </a:rPr>
-              <a:t>Perguntar</a:t>
+              <a:t>Serve para projeto novo</a:t>
             </a:r>
             <a:endParaRPr lang="en-US" sz="1800" dirty="0"/>
           </a:p>
@@ -3544,62 +4224,23 @@
       </p:sp>
       <p:sp>
         <p:nvSpPr>
-          <p:cNvPr id="11" name="Text 9"/>
-          <p:cNvSpPr txBox="1"/>
-          <p:nvPr/>
-        </p:nvSpPr>
-        <p:spPr>
-          <a:xfrm>
-            <a:off x="3611880" y="3017520"/>
-            <a:ext cx="2286000" cy="731520"/>
-          </a:xfrm>
-          <a:prstGeom prst="rect">
-            <a:avLst/>
-          </a:prstGeom>
-          <a:noFill/>
-          <a:ln/>
-        </p:spPr>
-        <p:txBody>
-          <a:bodyPr wrap="square" lIns="0" tIns="0" rIns="0" bIns="0" rtlCol="0" anchor="ctr"/>
-          <a:lstStyle/>
-          <a:p>
-            <a:pPr indent="0" marL="0">
-              <a:buNone/>
-            </a:pPr>
-            <a:r>
-              <a:rPr lang="en-US" sz="1100" dirty="0">
-                <a:solidFill>
-                  <a:srgbClr val="E2261C"/>
-                </a:solidFill>
-                <a:latin typeface="Courier New" pitchFamily="34" charset="0"/>
-                <a:ea typeface="Courier New" pitchFamily="34" charset="-122"/>
-                <a:cs typeface="Courier New" pitchFamily="34" charset="-120"/>
-              </a:rPr>
-              <a:t>/wx-claude-code:questionario</a:t>
-            </a:r>
-            <a:endParaRPr lang="en-US" sz="1100" dirty="0"/>
-          </a:p>
-        </p:txBody>
-      </p:sp>
-      <p:sp>
-        <p:nvSpPr>
-          <p:cNvPr id="12" name="Text 10"/>
-          <p:cNvSpPr txBox="1"/>
-          <p:nvPr/>
-        </p:nvSpPr>
-        <p:spPr>
-          <a:xfrm>
-            <a:off x="3611880" y="3840480"/>
-            <a:ext cx="2286000" cy="1645920"/>
-          </a:xfrm>
-          <a:prstGeom prst="rect">
-            <a:avLst/>
-          </a:prstGeom>
-          <a:noFill/>
-          <a:ln/>
-        </p:spPr>
-        <p:txBody>
-          <a:bodyPr wrap="square" lIns="0" tIns="0" rIns="0" bIns="0" rtlCol="0" anchor="ctr"/>
+          <p:cNvPr id="8" name="Text 6"/>
+          <p:cNvSpPr txBox="1"/>
+          <p:nvPr/>
+        </p:nvSpPr>
+        <p:spPr>
+          <a:xfrm>
+            <a:off x="6492240" y="2194560"/>
+            <a:ext cx="4846320" cy="1234440"/>
+          </a:xfrm>
+          <a:prstGeom prst="rect">
+            <a:avLst/>
+          </a:prstGeom>
+          <a:noFill/>
+          <a:ln/>
+        </p:spPr>
+        <p:txBody>
+          <a:bodyPr wrap="square" lIns="0" tIns="0" rIns="0" bIns="0" rtlCol="0" anchor="t"/>
           <a:lstStyle/>
           <a:p>
             <a:pPr indent="0" marL="0">
@@ -3614,7 +4255,7 @@
                 <a:ea typeface="Calibri" pitchFamily="34" charset="-122"/>
                 <a:cs typeface="Calibri" pitchFamily="34" charset="-120"/>
               </a:rPr>
-              <a:t>Sessenta perguntas, com pausa e retomada. Sai o contexto do projeto.</a:t>
+              <a:t>O mesmo questionário gera o esqueleto, os hooks, o PMO e a entrega auditável para quem não tem legado nenhum.</a:t>
             </a:r>
             <a:endParaRPr lang="en-US" sz="1300" dirty="0"/>
           </a:p>
@@ -3622,18 +4263,18 @@
       </p:sp>
       <p:sp>
         <p:nvSpPr>
-          <p:cNvPr id="13" name="Shape 11"/>
+          <p:cNvPr id="9" name="Shape 7"/>
           <p:cNvSpPr/>
           <p:nvPr/>
         </p:nvSpPr>
         <p:spPr>
           <a:xfrm>
-            <a:off x="6217920" y="1463040"/>
-            <a:ext cx="2651760" cy="4206240"/>
+            <a:off x="548640" y="3749040"/>
+            <a:ext cx="5394960" cy="2103120"/>
           </a:xfrm>
           <a:prstGeom prst="roundRect">
             <a:avLst>
-              <a:gd name="adj" fmla="val 4138"/>
+              <a:gd name="adj" fmla="val 6522"/>
             </a:avLst>
           </a:prstGeom>
           <a:solidFill>
@@ -3656,30 +4297,30 @@
       </p:sp>
       <p:sp>
         <p:nvSpPr>
-          <p:cNvPr id="14" name="Text 12"/>
-          <p:cNvSpPr txBox="1"/>
-          <p:nvPr/>
-        </p:nvSpPr>
-        <p:spPr>
-          <a:xfrm>
-            <a:off x="6446520" y="1645920"/>
-            <a:ext cx="914400" cy="822960"/>
-          </a:xfrm>
-          <a:prstGeom prst="rect">
-            <a:avLst/>
-          </a:prstGeom>
-          <a:noFill/>
-          <a:ln/>
-        </p:spPr>
-        <p:txBody>
-          <a:bodyPr wrap="square" lIns="0" tIns="0" rIns="0" bIns="0" rtlCol="0" anchor="ctr"/>
-          <a:lstStyle/>
-          <a:p>
-            <a:pPr indent="0" marL="0">
-              <a:buNone/>
-            </a:pPr>
-            <a:r>
-              <a:rPr lang="en-US" sz="4400" b="1" dirty="0">
+          <p:cNvPr id="10" name="Text 8"/>
+          <p:cNvSpPr txBox="1"/>
+          <p:nvPr/>
+        </p:nvSpPr>
+        <p:spPr>
+          <a:xfrm>
+            <a:off x="822960" y="3950208"/>
+            <a:ext cx="4846320" cy="548640"/>
+          </a:xfrm>
+          <a:prstGeom prst="rect">
+            <a:avLst/>
+          </a:prstGeom>
+          <a:noFill/>
+          <a:ln/>
+        </p:spPr>
+        <p:txBody>
+          <a:bodyPr wrap="square" lIns="0" tIns="0" rIns="0" bIns="0" rtlCol="0" anchor="t"/>
+          <a:lstStyle/>
+          <a:p>
+            <a:pPr indent="0" marL="0">
+              <a:buNone/>
+            </a:pPr>
+            <a:r>
+              <a:rPr lang="en-US" sz="1800" b="1" dirty="0">
                 <a:solidFill>
                   <a:srgbClr val="E2261C"/>
                 </a:solidFill>
@@ -3687,46 +4328,7 @@
                 <a:ea typeface="Century Schoolbook" pitchFamily="34" charset="-122"/>
                 <a:cs typeface="Century Schoolbook" pitchFamily="34" charset="-120"/>
               </a:rPr>
-              <a:t>3</a:t>
-            </a:r>
-            <a:endParaRPr lang="en-US" sz="4400" dirty="0"/>
-          </a:p>
-        </p:txBody>
-      </p:sp>
-      <p:sp>
-        <p:nvSpPr>
-          <p:cNvPr id="15" name="Text 13"/>
-          <p:cNvSpPr txBox="1"/>
-          <p:nvPr/>
-        </p:nvSpPr>
-        <p:spPr>
-          <a:xfrm>
-            <a:off x="6446520" y="2514600"/>
-            <a:ext cx="2286000" cy="457200"/>
-          </a:xfrm>
-          <a:prstGeom prst="rect">
-            <a:avLst/>
-          </a:prstGeom>
-          <a:noFill/>
-          <a:ln/>
-        </p:spPr>
-        <p:txBody>
-          <a:bodyPr wrap="square" lIns="0" tIns="0" rIns="0" bIns="0" rtlCol="0" anchor="ctr"/>
-          <a:lstStyle/>
-          <a:p>
-            <a:pPr indent="0" marL="0">
-              <a:buNone/>
-            </a:pPr>
-            <a:r>
-              <a:rPr lang="en-US" sz="1800" b="1" dirty="0">
-                <a:solidFill>
-                  <a:srgbClr val="14161F"/>
-                </a:solidFill>
-                <a:latin typeface="Calibri" pitchFamily="34" charset="0"/>
-                <a:ea typeface="Calibri" pitchFamily="34" charset="-122"/>
-                <a:cs typeface="Calibri" pitchFamily="34" charset="-120"/>
-              </a:rPr>
-              <a:t>Passar o G0</a:t>
+              <a:t>Custa menos do que parece</a:t>
             </a:r>
             <a:endParaRPr lang="en-US" sz="1800" dirty="0"/>
           </a:p>
@@ -3734,62 +4336,23 @@
       </p:sp>
       <p:sp>
         <p:nvSpPr>
-          <p:cNvPr id="16" name="Text 14"/>
-          <p:cNvSpPr txBox="1"/>
-          <p:nvPr/>
-        </p:nvSpPr>
-        <p:spPr>
-          <a:xfrm>
-            <a:off x="6446520" y="3017520"/>
-            <a:ext cx="2286000" cy="731520"/>
-          </a:xfrm>
-          <a:prstGeom prst="rect">
-            <a:avLst/>
-          </a:prstGeom>
-          <a:noFill/>
-          <a:ln/>
-        </p:spPr>
-        <p:txBody>
-          <a:bodyPr wrap="square" lIns="0" tIns="0" rIns="0" bIns="0" rtlCol="0" anchor="ctr"/>
-          <a:lstStyle/>
-          <a:p>
-            <a:pPr indent="0" marL="0">
-              <a:buNone/>
-            </a:pPr>
-            <a:r>
-              <a:rPr lang="en-US" sz="1100" dirty="0">
-                <a:solidFill>
-                  <a:srgbClr val="E2261C"/>
-                </a:solidFill>
-                <a:latin typeface="Courier New" pitchFamily="34" charset="0"/>
-                <a:ea typeface="Courier New" pitchFamily="34" charset="-122"/>
-                <a:cs typeface="Courier New" pitchFamily="34" charset="-120"/>
-              </a:rPr>
-              <a:t>/wx-claude-code:preflight</a:t>
-            </a:r>
-            <a:endParaRPr lang="en-US" sz="1100" dirty="0"/>
-          </a:p>
-        </p:txBody>
-      </p:sp>
-      <p:sp>
-        <p:nvSpPr>
-          <p:cNvPr id="17" name="Text 15"/>
-          <p:cNvSpPr txBox="1"/>
-          <p:nvPr/>
-        </p:nvSpPr>
-        <p:spPr>
-          <a:xfrm>
-            <a:off x="6446520" y="3840480"/>
-            <a:ext cx="2286000" cy="1645920"/>
-          </a:xfrm>
-          <a:prstGeom prst="rect">
-            <a:avLst/>
-          </a:prstGeom>
-          <a:noFill/>
-          <a:ln/>
-        </p:spPr>
-        <p:txBody>
-          <a:bodyPr wrap="square" lIns="0" tIns="0" rIns="0" bIns="0" rtlCol="0" anchor="ctr"/>
+          <p:cNvPr id="11" name="Text 9"/>
+          <p:cNvSpPr txBox="1"/>
+          <p:nvPr/>
+        </p:nvSpPr>
+        <p:spPr>
+          <a:xfrm>
+            <a:off x="822960" y="4526280"/>
+            <a:ext cx="4846320" cy="1234440"/>
+          </a:xfrm>
+          <a:prstGeom prst="rect">
+            <a:avLst/>
+          </a:prstGeom>
+          <a:noFill/>
+          <a:ln/>
+        </p:spPr>
+        <p:txBody>
+          <a:bodyPr wrap="square" lIns="0" tIns="0" rIns="0" bIns="0" rtlCol="0" anchor="t"/>
           <a:lstStyle/>
           <a:p>
             <a:pPr indent="0" marL="0">
@@ -3804,7 +4367,7 @@
                 <a:ea typeface="Calibri" pitchFamily="34" charset="-122"/>
                 <a:cs typeface="Calibri" pitchFamily="34" charset="-120"/>
               </a:rPr>
-              <a:t>Evidências com hash. O relatório diz a classe da prova e o limite.</a:t>
+              <a:t>Laudo de uso de tokens, roteador que escolhe o modelo pelo peso da tarefa, orçamento que bloqueia, modelo local para o que não precisa sair da máquina.</a:t>
             </a:r>
             <a:endParaRPr lang="en-US" sz="1300" dirty="0"/>
           </a:p>
@@ -3812,18 +4375,18 @@
       </p:sp>
       <p:sp>
         <p:nvSpPr>
-          <p:cNvPr id="18" name="Shape 16"/>
+          <p:cNvPr id="12" name="Shape 10"/>
           <p:cNvSpPr/>
           <p:nvPr/>
         </p:nvSpPr>
         <p:spPr>
           <a:xfrm>
-            <a:off x="9052560" y="1463040"/>
-            <a:ext cx="2651760" cy="4206240"/>
+            <a:off x="6217920" y="3749040"/>
+            <a:ext cx="5394960" cy="2103120"/>
           </a:xfrm>
           <a:prstGeom prst="roundRect">
             <a:avLst>
-              <a:gd name="adj" fmla="val 4138"/>
+              <a:gd name="adj" fmla="val 6522"/>
             </a:avLst>
           </a:prstGeom>
           <a:solidFill>
@@ -3846,30 +4409,30 @@
       </p:sp>
       <p:sp>
         <p:nvSpPr>
-          <p:cNvPr id="19" name="Text 17"/>
-          <p:cNvSpPr txBox="1"/>
-          <p:nvPr/>
-        </p:nvSpPr>
-        <p:spPr>
-          <a:xfrm>
-            <a:off x="9281160" y="1645920"/>
-            <a:ext cx="914400" cy="822960"/>
-          </a:xfrm>
-          <a:prstGeom prst="rect">
-            <a:avLst/>
-          </a:prstGeom>
-          <a:noFill/>
-          <a:ln/>
-        </p:spPr>
-        <p:txBody>
-          <a:bodyPr wrap="square" lIns="0" tIns="0" rIns="0" bIns="0" rtlCol="0" anchor="ctr"/>
-          <a:lstStyle/>
-          <a:p>
-            <a:pPr indent="0" marL="0">
-              <a:buNone/>
-            </a:pPr>
-            <a:r>
-              <a:rPr lang="en-US" sz="4400" b="1" dirty="0">
+          <p:cNvPr id="13" name="Text 11"/>
+          <p:cNvSpPr txBox="1"/>
+          <p:nvPr/>
+        </p:nvSpPr>
+        <p:spPr>
+          <a:xfrm>
+            <a:off x="6492240" y="3950208"/>
+            <a:ext cx="4846320" cy="548640"/>
+          </a:xfrm>
+          <a:prstGeom prst="rect">
+            <a:avLst/>
+          </a:prstGeom>
+          <a:noFill/>
+          <a:ln/>
+        </p:spPr>
+        <p:txBody>
+          <a:bodyPr wrap="square" lIns="0" tIns="0" rIns="0" bIns="0" rtlCol="0" anchor="t"/>
+          <a:lstStyle/>
+          <a:p>
+            <a:pPr indent="0" marL="0">
+              <a:buNone/>
+            </a:pPr>
+            <a:r>
+              <a:rPr lang="en-US" sz="1800" b="1" dirty="0">
                 <a:solidFill>
                   <a:srgbClr val="E2261C"/>
                 </a:solidFill>
@@ -3877,46 +4440,7 @@
                 <a:ea typeface="Century Schoolbook" pitchFamily="34" charset="-122"/>
                 <a:cs typeface="Century Schoolbook" pitchFamily="34" charset="-120"/>
               </a:rPr>
-              <a:t>4</a:t>
-            </a:r>
-            <a:endParaRPr lang="en-US" sz="4400" dirty="0"/>
-          </a:p>
-        </p:txBody>
-      </p:sp>
-      <p:sp>
-        <p:nvSpPr>
-          <p:cNvPr id="20" name="Text 18"/>
-          <p:cNvSpPr txBox="1"/>
-          <p:nvPr/>
-        </p:nvSpPr>
-        <p:spPr>
-          <a:xfrm>
-            <a:off x="9281160" y="2514600"/>
-            <a:ext cx="2286000" cy="457200"/>
-          </a:xfrm>
-          <a:prstGeom prst="rect">
-            <a:avLst/>
-          </a:prstGeom>
-          <a:noFill/>
-          <a:ln/>
-        </p:spPr>
-        <p:txBody>
-          <a:bodyPr wrap="square" lIns="0" tIns="0" rIns="0" bIns="0" rtlCol="0" anchor="ctr"/>
-          <a:lstStyle/>
-          <a:p>
-            <a:pPr indent="0" marL="0">
-              <a:buNone/>
-            </a:pPr>
-            <a:r>
-              <a:rPr lang="en-US" sz="1800" b="1" dirty="0">
-                <a:solidFill>
-                  <a:srgbClr val="14161F"/>
-                </a:solidFill>
-                <a:latin typeface="Calibri" pitchFamily="34" charset="0"/>
-                <a:ea typeface="Calibri" pitchFamily="34" charset="-122"/>
-                <a:cs typeface="Calibri" pitchFamily="34" charset="-120"/>
-              </a:rPr>
-              <a:t>Piloto com prova</a:t>
+              <a:t>O mais forte: o que ele admite não fazer</a:t>
             </a:r>
             <a:endParaRPr lang="en-US" sz="1800" dirty="0"/>
           </a:p>
@@ -3924,62 +4448,23 @@
       </p:sp>
       <p:sp>
         <p:nvSpPr>
-          <p:cNvPr id="21" name="Text 19"/>
-          <p:cNvSpPr txBox="1"/>
-          <p:nvPr/>
-        </p:nvSpPr>
-        <p:spPr>
-          <a:xfrm>
-            <a:off x="9281160" y="3017520"/>
-            <a:ext cx="2286000" cy="731520"/>
-          </a:xfrm>
-          <a:prstGeom prst="rect">
-            <a:avLst/>
-          </a:prstGeom>
-          <a:noFill/>
-          <a:ln/>
-        </p:spPr>
-        <p:txBody>
-          <a:bodyPr wrap="square" lIns="0" tIns="0" rIns="0" bIns="0" rtlCol="0" anchor="ctr"/>
-          <a:lstStyle/>
-          <a:p>
-            <a:pPr indent="0" marL="0">
-              <a:buNone/>
-            </a:pPr>
-            <a:r>
-              <a:rPr lang="en-US" sz="1100" dirty="0">
-                <a:solidFill>
-                  <a:srgbClr val="E2261C"/>
-                </a:solidFill>
-                <a:latin typeface="Courier New" pitchFamily="34" charset="0"/>
-                <a:ea typeface="Courier New" pitchFamily="34" charset="-122"/>
-                <a:cs typeface="Courier New" pitchFamily="34" charset="-120"/>
-              </a:rPr>
-              <a:t>/wx-claude-code:golden comparar</a:t>
-            </a:r>
-            <a:endParaRPr lang="en-US" sz="1100" dirty="0"/>
-          </a:p>
-        </p:txBody>
-      </p:sp>
-      <p:sp>
-        <p:nvSpPr>
-          <p:cNvPr id="22" name="Text 20"/>
-          <p:cNvSpPr txBox="1"/>
-          <p:nvPr/>
-        </p:nvSpPr>
-        <p:spPr>
-          <a:xfrm>
-            <a:off x="9281160" y="3840480"/>
-            <a:ext cx="2286000" cy="1645920"/>
-          </a:xfrm>
-          <a:prstGeom prst="rect">
-            <a:avLst/>
-          </a:prstGeom>
-          <a:noFill/>
-          <a:ln/>
-        </p:spPr>
-        <p:txBody>
-          <a:bodyPr wrap="square" lIns="0" tIns="0" rIns="0" bIns="0" rtlCol="0" anchor="ctr"/>
+          <p:cNvPr id="14" name="Text 12"/>
+          <p:cNvSpPr txBox="1"/>
+          <p:nvPr/>
+        </p:nvSpPr>
+        <p:spPr>
+          <a:xfrm>
+            <a:off x="6492240" y="4526280"/>
+            <a:ext cx="4846320" cy="1234440"/>
+          </a:xfrm>
+          <a:prstGeom prst="rect">
+            <a:avLst/>
+          </a:prstGeom>
+          <a:noFill/>
+          <a:ln/>
+        </p:spPr>
+        <p:txBody>
+          <a:bodyPr wrap="square" lIns="0" tIns="0" rIns="0" bIns="0" rtlCol="0" anchor="t"/>
           <a:lstStyle/>
           <a:p>
             <a:pPr indent="0" marL="0">
@@ -3994,7 +4479,7 @@
                 <a:ea typeface="Calibri" pitchFamily="34" charset="-122"/>
                 <a:cs typeface="Calibri" pitchFamily="34" charset="-120"/>
               </a:rPr>
-              <a:t>Uma vertical inteira, igualdade em número. Daí, as ondas.</a:t>
+              <a:t>Não lê o binário do WX, não faz OCR sozinho, não certifica LGPD, não aprova gate no lugar de gente. Quem esconde limites vende promessa. Quem publica limites vende ferramenta.</a:t>
             </a:r>
             <a:endParaRPr lang="en-US" sz="1300" dirty="0"/>
           </a:p>
@@ -4002,46 +4487,7 @@
       </p:sp>
       <p:sp>
         <p:nvSpPr>
-          <p:cNvPr id="23" name="Text 21"/>
-          <p:cNvSpPr txBox="1"/>
-          <p:nvPr/>
-        </p:nvSpPr>
-        <p:spPr>
-          <a:xfrm>
-            <a:off x="548640" y="5943600"/>
-            <a:ext cx="11064240" cy="365760"/>
-          </a:xfrm>
-          <a:prstGeom prst="rect">
-            <a:avLst/>
-          </a:prstGeom>
-          <a:noFill/>
-          <a:ln/>
-        </p:spPr>
-        <p:txBody>
-          <a:bodyPr wrap="square" lIns="0" tIns="0" rIns="0" bIns="0" rtlCol="0" anchor="ctr"/>
-          <a:lstStyle/>
-          <a:p>
-            <a:pPr indent="0" marL="0">
-              <a:buNone/>
-            </a:pPr>
-            <a:r>
-              <a:rPr lang="en-US" sz="1200" dirty="0">
-                <a:solidFill>
-                  <a:srgbClr val="6B6F82"/>
-                </a:solidFill>
-                <a:latin typeface="Calibri" pitchFamily="34" charset="0"/>
-                <a:ea typeface="Calibri" pitchFamily="34" charset="-122"/>
-                <a:cs typeface="Calibri" pitchFamily="34" charset="-120"/>
-              </a:rPr>
-              <a:t>Manual: MANUAL.md e docs/manual-de-uso.pdf · Fluxograma: docs/dossie/fluxo-atual.pdf · Vídeos: docs/video/</a:t>
-            </a:r>
-            <a:endParaRPr lang="en-US" sz="1200" dirty="0"/>
-          </a:p>
-        </p:txBody>
-      </p:sp>
-      <p:sp>
-        <p:nvSpPr>
-          <p:cNvPr id="24" name="Text 22"/>
+          <p:cNvPr id="15" name="Text 13"/>
           <p:cNvSpPr txBox="1"/>
           <p:nvPr/>
         </p:nvSpPr>
@@ -4072,7 +4518,7 @@
                 <a:ea typeface="Calibri" pitchFamily="34" charset="-122"/>
                 <a:cs typeface="Calibri" pitchFamily="34" charset="-120"/>
               </a:rPr>
-              <a:t>WX Claude Code 3.46.0 · Built to convert. Engineered to prove.</a:t>
+              <a:t>WX Claude Code 3.48.0 · Built to convert. Engineered to prove.</a:t>
             </a:r>
             <a:endParaRPr lang="en-US" sz="1000" dirty="0"/>
           </a:p>
@@ -4086,9 +4532,1172 @@
 </p:sld>
 </file>
 
-<file path=ppt/slides/slide13.xml><?xml version="1.0" encoding="utf-8"?>
+<file path=ppt/slides/slide14.xml><?xml version="1.0" encoding="utf-8"?>
 <p:sld xmlns:a="http://schemas.openxmlformats.org/drawingml/2006/main" xmlns:r="http://schemas.openxmlformats.org/officeDocument/2006/relationships" xmlns:p="http://schemas.openxmlformats.org/presentationml/2006/main">
-  <p:cSld name="Slide 13">
+  <p:cSld name="Slide 14">
+    <p:bg>
+      <p:bgPr>
+        <a:solidFill>
+          <a:srgbClr val="010418"/>
+        </a:solidFill>
+      </p:bgPr>
+    </p:bg>
+    <p:spTree>
+      <p:nvGrpSpPr>
+        <p:cNvPr id="1" name=""/>
+        <p:cNvGrpSpPr/>
+        <p:nvPr/>
+      </p:nvGrpSpPr>
+      <p:grpSpPr>
+        <a:xfrm>
+          <a:off x="0" y="0"/>
+          <a:ext cx="0" cy="0"/>
+          <a:chOff x="0" y="0"/>
+          <a:chExt cx="0" cy="0"/>
+        </a:xfrm>
+      </p:grpSpPr>
+      <p:sp>
+        <p:nvSpPr>
+          <p:cNvPr id="2" name="Text 0"/>
+          <p:cNvSpPr txBox="1"/>
+          <p:nvPr/>
+        </p:nvSpPr>
+        <p:spPr>
+          <a:xfrm>
+            <a:off x="548640" y="411480"/>
+            <a:ext cx="11064240" cy="822960"/>
+          </a:xfrm>
+          <a:prstGeom prst="rect">
+            <a:avLst/>
+          </a:prstGeom>
+          <a:noFill/>
+          <a:ln/>
+        </p:spPr>
+        <p:txBody>
+          <a:bodyPr wrap="square" lIns="0" tIns="0" rIns="0" bIns="0" rtlCol="0" anchor="ctr"/>
+          <a:lstStyle/>
+          <a:p>
+            <a:pPr indent="0" marL="0">
+              <a:buNone/>
+            </a:pPr>
+            <a:r>
+              <a:rPr lang="en-US" sz="3400" b="1" dirty="0">
+                <a:solidFill>
+                  <a:srgbClr val="FFFFFF"/>
+                </a:solidFill>
+                <a:latin typeface="Century Schoolbook" pitchFamily="34" charset="0"/>
+                <a:ea typeface="Century Schoolbook" pitchFamily="34" charset="-122"/>
+                <a:cs typeface="Century Schoolbook" pitchFamily="34" charset="-120"/>
+              </a:rPr>
+              <a:t>A objeção honesta</a:t>
+            </a:r>
+            <a:endParaRPr lang="en-US" sz="3400" dirty="0"/>
+          </a:p>
+        </p:txBody>
+      </p:sp>
+      <p:sp>
+        <p:nvSpPr>
+          <p:cNvPr id="3" name="Shape 1"/>
+          <p:cNvSpPr/>
+          <p:nvPr/>
+        </p:nvSpPr>
+        <p:spPr>
+          <a:xfrm>
+            <a:off x="548640" y="1554480"/>
+            <a:ext cx="11064240" cy="2926080"/>
+          </a:xfrm>
+          <a:prstGeom prst="roundRect">
+            <a:avLst>
+              <a:gd name="adj" fmla="val 4688"/>
+            </a:avLst>
+          </a:prstGeom>
+          <a:solidFill>
+            <a:srgbClr val="121527"/>
+          </a:solidFill>
+          <a:ln w="12700">
+            <a:solidFill>
+              <a:srgbClr val="2E3454"/>
+            </a:solidFill>
+            <a:prstDash val="solid"/>
+          </a:ln>
+        </p:spPr>
+      </p:sp>
+      <p:sp>
+        <p:nvSpPr>
+          <p:cNvPr id="4" name="Text 2"/>
+          <p:cNvSpPr txBox="1"/>
+          <p:nvPr/>
+        </p:nvSpPr>
+        <p:spPr>
+          <a:xfrm>
+            <a:off x="914400" y="1828800"/>
+            <a:ext cx="10332720" cy="914400"/>
+          </a:xfrm>
+          <a:prstGeom prst="rect">
+            <a:avLst/>
+          </a:prstGeom>
+          <a:noFill/>
+          <a:ln/>
+        </p:spPr>
+        <p:txBody>
+          <a:bodyPr wrap="square" lIns="0" tIns="0" rIns="0" bIns="0" rtlCol="0" anchor="ctr"/>
+          <a:lstStyle/>
+          <a:p>
+            <a:pPr indent="0" marL="0">
+              <a:buNone/>
+            </a:pPr>
+            <a:r>
+              <a:rPr lang="en-US" sz="2800" b="1" dirty="0">
+                <a:solidFill>
+                  <a:srgbClr val="F7B733"/>
+                </a:solidFill>
+                <a:latin typeface="Century Schoolbook" pitchFamily="34" charset="0"/>
+                <a:ea typeface="Century Schoolbook" pitchFamily="34" charset="-122"/>
+                <a:cs typeface="Century Schoolbook" pitchFamily="34" charset="-120"/>
+              </a:rPr>
+              <a:t>Nenhum projeto WINDEV real com contrato passou pelos gates ainda.</a:t>
+            </a:r>
+            <a:endParaRPr lang="en-US" sz="2800" dirty="0"/>
+          </a:p>
+        </p:txBody>
+      </p:sp>
+      <p:sp>
+        <p:nvSpPr>
+          <p:cNvPr id="5" name="Text 3"/>
+          <p:cNvSpPr txBox="1"/>
+          <p:nvPr/>
+        </p:nvSpPr>
+        <p:spPr>
+          <a:xfrm>
+            <a:off x="914400" y="2834640"/>
+            <a:ext cx="10332720" cy="1463040"/>
+          </a:xfrm>
+          <a:prstGeom prst="rect">
+            <a:avLst/>
+          </a:prstGeom>
+          <a:noFill/>
+          <a:ln/>
+        </p:spPr>
+        <p:txBody>
+          <a:bodyPr wrap="square" lIns="0" tIns="0" rIns="0" bIns="0" rtlCol="0" anchor="ctr"/>
+          <a:lstStyle/>
+          <a:p>
+            <a:pPr indent="0" marL="0">
+              <a:buNone/>
+            </a:pPr>
+            <a:r>
+              <a:rPr lang="en-US" sz="1600" dirty="0">
+                <a:solidFill>
+                  <a:srgbClr val="EDEDF3"/>
+                </a:solidFill>
+                <a:latin typeface="Calibri" pitchFamily="34" charset="0"/>
+                <a:ea typeface="Calibri" pitchFamily="34" charset="-122"/>
+                <a:cs typeface="Calibri" pitchFamily="34" charset="-120"/>
+              </a:rPr>
+              <a:t>Os exemplos são sintéticos. Isso está escrito como item 15 da lista do que falta, com estado medido por item — e é o que um primeiro cliente piloto compra com desconto e paga com o número que falta: horas, tokens, lacunas abertas, defeitos achados em homologação.</a:t>
+            </a:r>
+            <a:endParaRPr lang="en-US" sz="1600" dirty="0"/>
+          </a:p>
+        </p:txBody>
+      </p:sp>
+      <p:sp>
+        <p:nvSpPr>
+          <p:cNvPr id="6" name="Text 4"/>
+          <p:cNvSpPr txBox="1"/>
+          <p:nvPr/>
+        </p:nvSpPr>
+        <p:spPr>
+          <a:xfrm>
+            <a:off x="548640" y="4846320"/>
+            <a:ext cx="10972800" cy="457200"/>
+          </a:xfrm>
+          <a:prstGeom prst="rect">
+            <a:avLst/>
+          </a:prstGeom>
+          <a:noFill/>
+          <a:ln/>
+        </p:spPr>
+        <p:txBody>
+          <a:bodyPr wrap="square" lIns="0" tIns="0" rIns="0" bIns="0" rtlCol="0" anchor="ctr"/>
+          <a:lstStyle/>
+          <a:p>
+            <a:pPr indent="0" marL="0">
+              <a:buNone/>
+            </a:pPr>
+            <a:r>
+              <a:rPr lang="en-US" sz="1300" i="1" dirty="0">
+                <a:solidFill>
+                  <a:srgbClr val="9AA0B8"/>
+                </a:solidFill>
+                <a:latin typeface="Calibri" pitchFamily="34" charset="0"/>
+                <a:ea typeface="Calibri" pitchFamily="34" charset="-122"/>
+                <a:cs typeface="Calibri" pitchFamily="34" charset="-120"/>
+              </a:rPr>
+              <a:t>A lista inteira: docs/o-que-falta.html</a:t>
+            </a:r>
+            <a:endParaRPr lang="en-US" sz="1300" dirty="0"/>
+          </a:p>
+        </p:txBody>
+      </p:sp>
+      <p:sp>
+        <p:nvSpPr>
+          <p:cNvPr id="7" name="Text 5"/>
+          <p:cNvSpPr txBox="1"/>
+          <p:nvPr/>
+        </p:nvSpPr>
+        <p:spPr>
+          <a:xfrm>
+            <a:off x="548640" y="6400800"/>
+            <a:ext cx="8229600" cy="274320"/>
+          </a:xfrm>
+          <a:prstGeom prst="rect">
+            <a:avLst/>
+          </a:prstGeom>
+          <a:noFill/>
+          <a:ln/>
+        </p:spPr>
+        <p:txBody>
+          <a:bodyPr wrap="square" lIns="0" tIns="0" rIns="0" bIns="0" rtlCol="0" anchor="ctr"/>
+          <a:lstStyle/>
+          <a:p>
+            <a:pPr indent="0" marL="0">
+              <a:buNone/>
+            </a:pPr>
+            <a:r>
+              <a:rPr lang="en-US" sz="1000" dirty="0">
+                <a:solidFill>
+                  <a:srgbClr val="9AA0B8"/>
+                </a:solidFill>
+                <a:latin typeface="Calibri" pitchFamily="34" charset="0"/>
+                <a:ea typeface="Calibri" pitchFamily="34" charset="-122"/>
+                <a:cs typeface="Calibri" pitchFamily="34" charset="-120"/>
+              </a:rPr>
+              <a:t>WX Claude Code 3.48.0 · Built to convert. Engineered to prove.</a:t>
+            </a:r>
+            <a:endParaRPr lang="en-US" sz="1000" dirty="0"/>
+          </a:p>
+        </p:txBody>
+      </p:sp>
+    </p:spTree>
+  </p:cSld>
+  <p:clrMapOvr>
+    <a:masterClrMapping/>
+  </p:clrMapOvr>
+</p:sld>
+</file>
+
+<file path=ppt/slides/slide15.xml><?xml version="1.0" encoding="utf-8"?>
+<p:sld xmlns:a="http://schemas.openxmlformats.org/drawingml/2006/main" xmlns:r="http://schemas.openxmlformats.org/officeDocument/2006/relationships" xmlns:p="http://schemas.openxmlformats.org/presentationml/2006/main">
+  <p:cSld name="Slide 15">
+    <p:bg>
+      <p:bgPr>
+        <a:solidFill>
+          <a:srgbClr val="FBFAF7"/>
+        </a:solidFill>
+      </p:bgPr>
+    </p:bg>
+    <p:spTree>
+      <p:nvGrpSpPr>
+        <p:cNvPr id="1" name=""/>
+        <p:cNvGrpSpPr/>
+        <p:nvPr/>
+      </p:nvGrpSpPr>
+      <p:grpSpPr>
+        <a:xfrm>
+          <a:off x="0" y="0"/>
+          <a:ext cx="0" cy="0"/>
+          <a:chOff x="0" y="0"/>
+          <a:chExt cx="0" cy="0"/>
+        </a:xfrm>
+      </p:grpSpPr>
+      <p:sp>
+        <p:nvSpPr>
+          <p:cNvPr id="2" name="Text 0"/>
+          <p:cNvSpPr txBox="1"/>
+          <p:nvPr/>
+        </p:nvSpPr>
+        <p:spPr>
+          <a:xfrm>
+            <a:off x="548640" y="411480"/>
+            <a:ext cx="11064240" cy="822960"/>
+          </a:xfrm>
+          <a:prstGeom prst="rect">
+            <a:avLst/>
+          </a:prstGeom>
+          <a:noFill/>
+          <a:ln/>
+        </p:spPr>
+        <p:txBody>
+          <a:bodyPr wrap="square" lIns="0" tIns="0" rIns="0" bIns="0" rtlCol="0" anchor="ctr"/>
+          <a:lstStyle/>
+          <a:p>
+            <a:pPr indent="0" marL="0">
+              <a:buNone/>
+            </a:pPr>
+            <a:r>
+              <a:rPr lang="en-US" sz="3400" b="1" dirty="0">
+                <a:solidFill>
+                  <a:srgbClr val="14161F"/>
+                </a:solidFill>
+                <a:latin typeface="Century Schoolbook" pitchFamily="34" charset="0"/>
+                <a:ea typeface="Century Schoolbook" pitchFamily="34" charset="-122"/>
+                <a:cs typeface="Century Schoolbook" pitchFamily="34" charset="-120"/>
+              </a:rPr>
+              <a:t>Como começar: quatro passos</a:t>
+            </a:r>
+            <a:endParaRPr lang="en-US" sz="3400" dirty="0"/>
+          </a:p>
+        </p:txBody>
+      </p:sp>
+      <p:sp>
+        <p:nvSpPr>
+          <p:cNvPr id="3" name="Shape 1"/>
+          <p:cNvSpPr/>
+          <p:nvPr/>
+        </p:nvSpPr>
+        <p:spPr>
+          <a:xfrm>
+            <a:off x="548640" y="1463040"/>
+            <a:ext cx="2651760" cy="4206240"/>
+          </a:xfrm>
+          <a:prstGeom prst="roundRect">
+            <a:avLst>
+              <a:gd name="adj" fmla="val 4138"/>
+            </a:avLst>
+          </a:prstGeom>
+          <a:solidFill>
+            <a:srgbClr val="FFFFFF"/>
+          </a:solidFill>
+          <a:ln w="12700">
+            <a:solidFill>
+              <a:srgbClr val="E4E2DB"/>
+            </a:solidFill>
+            <a:prstDash val="solid"/>
+          </a:ln>
+          <a:effectLst>
+            <a:outerShdw sx="100000" sy="100000" kx="0" ky="0" algn="bl" rotWithShape="0" blurRad="76200" dist="25400" dir="5400000">
+              <a:srgbClr val="000000">
+                <a:alpha val="8000"/>
+              </a:srgbClr>
+            </a:outerShdw>
+          </a:effectLst>
+        </p:spPr>
+      </p:sp>
+      <p:sp>
+        <p:nvSpPr>
+          <p:cNvPr id="4" name="Text 2"/>
+          <p:cNvSpPr txBox="1"/>
+          <p:nvPr/>
+        </p:nvSpPr>
+        <p:spPr>
+          <a:xfrm>
+            <a:off x="777240" y="1645920"/>
+            <a:ext cx="914400" cy="822960"/>
+          </a:xfrm>
+          <a:prstGeom prst="rect">
+            <a:avLst/>
+          </a:prstGeom>
+          <a:noFill/>
+          <a:ln/>
+        </p:spPr>
+        <p:txBody>
+          <a:bodyPr wrap="square" lIns="0" tIns="0" rIns="0" bIns="0" rtlCol="0" anchor="ctr"/>
+          <a:lstStyle/>
+          <a:p>
+            <a:pPr indent="0" marL="0">
+              <a:buNone/>
+            </a:pPr>
+            <a:r>
+              <a:rPr lang="en-US" sz="4400" b="1" dirty="0">
+                <a:solidFill>
+                  <a:srgbClr val="E2261C"/>
+                </a:solidFill>
+                <a:latin typeface="Century Schoolbook" pitchFamily="34" charset="0"/>
+                <a:ea typeface="Century Schoolbook" pitchFamily="34" charset="-122"/>
+                <a:cs typeface="Century Schoolbook" pitchFamily="34" charset="-120"/>
+              </a:rPr>
+              <a:t>1</a:t>
+            </a:r>
+            <a:endParaRPr lang="en-US" sz="4400" dirty="0"/>
+          </a:p>
+        </p:txBody>
+      </p:sp>
+      <p:sp>
+        <p:nvSpPr>
+          <p:cNvPr id="5" name="Text 3"/>
+          <p:cNvSpPr txBox="1"/>
+          <p:nvPr/>
+        </p:nvSpPr>
+        <p:spPr>
+          <a:xfrm>
+            <a:off x="777240" y="2514600"/>
+            <a:ext cx="2286000" cy="457200"/>
+          </a:xfrm>
+          <a:prstGeom prst="rect">
+            <a:avLst/>
+          </a:prstGeom>
+          <a:noFill/>
+          <a:ln/>
+        </p:spPr>
+        <p:txBody>
+          <a:bodyPr wrap="square" lIns="0" tIns="0" rIns="0" bIns="0" rtlCol="0" anchor="ctr"/>
+          <a:lstStyle/>
+          <a:p>
+            <a:pPr indent="0" marL="0">
+              <a:buNone/>
+            </a:pPr>
+            <a:r>
+              <a:rPr lang="en-US" sz="1800" b="1" dirty="0">
+                <a:solidFill>
+                  <a:srgbClr val="14161F"/>
+                </a:solidFill>
+                <a:latin typeface="Calibri" pitchFamily="34" charset="0"/>
+                <a:ea typeface="Calibri" pitchFamily="34" charset="-122"/>
+                <a:cs typeface="Calibri" pitchFamily="34" charset="-120"/>
+              </a:rPr>
+              <a:t>Instalar</a:t>
+            </a:r>
+            <a:endParaRPr lang="en-US" sz="1800" dirty="0"/>
+          </a:p>
+        </p:txBody>
+      </p:sp>
+      <p:sp>
+        <p:nvSpPr>
+          <p:cNvPr id="6" name="Text 4"/>
+          <p:cNvSpPr txBox="1"/>
+          <p:nvPr/>
+        </p:nvSpPr>
+        <p:spPr>
+          <a:xfrm>
+            <a:off x="777240" y="3017520"/>
+            <a:ext cx="2286000" cy="731520"/>
+          </a:xfrm>
+          <a:prstGeom prst="rect">
+            <a:avLst/>
+          </a:prstGeom>
+          <a:noFill/>
+          <a:ln/>
+        </p:spPr>
+        <p:txBody>
+          <a:bodyPr wrap="square" lIns="0" tIns="0" rIns="0" bIns="0" rtlCol="0" anchor="ctr"/>
+          <a:lstStyle/>
+          <a:p>
+            <a:pPr indent="0" marL="0">
+              <a:buNone/>
+            </a:pPr>
+            <a:r>
+              <a:rPr lang="en-US" sz="1100" dirty="0">
+                <a:solidFill>
+                  <a:srgbClr val="E2261C"/>
+                </a:solidFill>
+                <a:latin typeface="Courier New" pitchFamily="34" charset="0"/>
+                <a:ea typeface="Courier New" pitchFamily="34" charset="-122"/>
+                <a:cs typeface="Courier New" pitchFamily="34" charset="-120"/>
+              </a:rPr>
+              <a:t>./instalar.sh --serial … --corpus …</a:t>
+            </a:r>
+            <a:endParaRPr lang="en-US" sz="1100" dirty="0"/>
+          </a:p>
+        </p:txBody>
+      </p:sp>
+      <p:sp>
+        <p:nvSpPr>
+          <p:cNvPr id="7" name="Text 5"/>
+          <p:cNvSpPr txBox="1"/>
+          <p:nvPr/>
+        </p:nvSpPr>
+        <p:spPr>
+          <a:xfrm>
+            <a:off x="777240" y="3840480"/>
+            <a:ext cx="2286000" cy="1645920"/>
+          </a:xfrm>
+          <a:prstGeom prst="rect">
+            <a:avLst/>
+          </a:prstGeom>
+          <a:noFill/>
+          <a:ln/>
+        </p:spPr>
+        <p:txBody>
+          <a:bodyPr wrap="square" lIns="0" tIns="0" rIns="0" bIns="0" rtlCol="0" anchor="ctr"/>
+          <a:lstStyle/>
+          <a:p>
+            <a:pPr indent="0" marL="0">
+              <a:buNone/>
+            </a:pPr>
+            <a:r>
+              <a:rPr lang="en-US" sz="1300" dirty="0">
+                <a:solidFill>
+                  <a:srgbClr val="6B6F82"/>
+                </a:solidFill>
+                <a:latin typeface="Calibri" pitchFamily="34" charset="0"/>
+                <a:ea typeface="Calibri" pitchFamily="34" charset="-122"/>
+                <a:cs typeface="Calibri" pitchFamily="34" charset="-120"/>
+              </a:rPr>
+              <a:t>Uma vez por máquina. Aceita a licença, confere o corpus, instala no Claude Code.</a:t>
+            </a:r>
+            <a:endParaRPr lang="en-US" sz="1300" dirty="0"/>
+          </a:p>
+        </p:txBody>
+      </p:sp>
+      <p:sp>
+        <p:nvSpPr>
+          <p:cNvPr id="8" name="Shape 6"/>
+          <p:cNvSpPr/>
+          <p:nvPr/>
+        </p:nvSpPr>
+        <p:spPr>
+          <a:xfrm>
+            <a:off x="3383280" y="1463040"/>
+            <a:ext cx="2651760" cy="4206240"/>
+          </a:xfrm>
+          <a:prstGeom prst="roundRect">
+            <a:avLst>
+              <a:gd name="adj" fmla="val 4138"/>
+            </a:avLst>
+          </a:prstGeom>
+          <a:solidFill>
+            <a:srgbClr val="FFFFFF"/>
+          </a:solidFill>
+          <a:ln w="12700">
+            <a:solidFill>
+              <a:srgbClr val="E4E2DB"/>
+            </a:solidFill>
+            <a:prstDash val="solid"/>
+          </a:ln>
+          <a:effectLst>
+            <a:outerShdw sx="100000" sy="100000" kx="0" ky="0" algn="bl" rotWithShape="0" blurRad="76200" dist="25400" dir="5400000">
+              <a:srgbClr val="000000">
+                <a:alpha val="8000"/>
+              </a:srgbClr>
+            </a:outerShdw>
+          </a:effectLst>
+        </p:spPr>
+      </p:sp>
+      <p:sp>
+        <p:nvSpPr>
+          <p:cNvPr id="9" name="Text 7"/>
+          <p:cNvSpPr txBox="1"/>
+          <p:nvPr/>
+        </p:nvSpPr>
+        <p:spPr>
+          <a:xfrm>
+            <a:off x="3611880" y="1645920"/>
+            <a:ext cx="914400" cy="822960"/>
+          </a:xfrm>
+          <a:prstGeom prst="rect">
+            <a:avLst/>
+          </a:prstGeom>
+          <a:noFill/>
+          <a:ln/>
+        </p:spPr>
+        <p:txBody>
+          <a:bodyPr wrap="square" lIns="0" tIns="0" rIns="0" bIns="0" rtlCol="0" anchor="ctr"/>
+          <a:lstStyle/>
+          <a:p>
+            <a:pPr indent="0" marL="0">
+              <a:buNone/>
+            </a:pPr>
+            <a:r>
+              <a:rPr lang="en-US" sz="4400" b="1" dirty="0">
+                <a:solidFill>
+                  <a:srgbClr val="E2261C"/>
+                </a:solidFill>
+                <a:latin typeface="Century Schoolbook" pitchFamily="34" charset="0"/>
+                <a:ea typeface="Century Schoolbook" pitchFamily="34" charset="-122"/>
+                <a:cs typeface="Century Schoolbook" pitchFamily="34" charset="-120"/>
+              </a:rPr>
+              <a:t>2</a:t>
+            </a:r>
+            <a:endParaRPr lang="en-US" sz="4400" dirty="0"/>
+          </a:p>
+        </p:txBody>
+      </p:sp>
+      <p:sp>
+        <p:nvSpPr>
+          <p:cNvPr id="10" name="Text 8"/>
+          <p:cNvSpPr txBox="1"/>
+          <p:nvPr/>
+        </p:nvSpPr>
+        <p:spPr>
+          <a:xfrm>
+            <a:off x="3611880" y="2514600"/>
+            <a:ext cx="2286000" cy="457200"/>
+          </a:xfrm>
+          <a:prstGeom prst="rect">
+            <a:avLst/>
+          </a:prstGeom>
+          <a:noFill/>
+          <a:ln/>
+        </p:spPr>
+        <p:txBody>
+          <a:bodyPr wrap="square" lIns="0" tIns="0" rIns="0" bIns="0" rtlCol="0" anchor="ctr"/>
+          <a:lstStyle/>
+          <a:p>
+            <a:pPr indent="0" marL="0">
+              <a:buNone/>
+            </a:pPr>
+            <a:r>
+              <a:rPr lang="en-US" sz="1800" b="1" dirty="0">
+                <a:solidFill>
+                  <a:srgbClr val="14161F"/>
+                </a:solidFill>
+                <a:latin typeface="Calibri" pitchFamily="34" charset="0"/>
+                <a:ea typeface="Calibri" pitchFamily="34" charset="-122"/>
+                <a:cs typeface="Calibri" pitchFamily="34" charset="-120"/>
+              </a:rPr>
+              <a:t>Perguntar</a:t>
+            </a:r>
+            <a:endParaRPr lang="en-US" sz="1800" dirty="0"/>
+          </a:p>
+        </p:txBody>
+      </p:sp>
+      <p:sp>
+        <p:nvSpPr>
+          <p:cNvPr id="11" name="Text 9"/>
+          <p:cNvSpPr txBox="1"/>
+          <p:nvPr/>
+        </p:nvSpPr>
+        <p:spPr>
+          <a:xfrm>
+            <a:off x="3611880" y="3017520"/>
+            <a:ext cx="2286000" cy="731520"/>
+          </a:xfrm>
+          <a:prstGeom prst="rect">
+            <a:avLst/>
+          </a:prstGeom>
+          <a:noFill/>
+          <a:ln/>
+        </p:spPr>
+        <p:txBody>
+          <a:bodyPr wrap="square" lIns="0" tIns="0" rIns="0" bIns="0" rtlCol="0" anchor="ctr"/>
+          <a:lstStyle/>
+          <a:p>
+            <a:pPr indent="0" marL="0">
+              <a:buNone/>
+            </a:pPr>
+            <a:r>
+              <a:rPr lang="en-US" sz="1100" dirty="0">
+                <a:solidFill>
+                  <a:srgbClr val="E2261C"/>
+                </a:solidFill>
+                <a:latin typeface="Courier New" pitchFamily="34" charset="0"/>
+                <a:ea typeface="Courier New" pitchFamily="34" charset="-122"/>
+                <a:cs typeface="Courier New" pitchFamily="34" charset="-120"/>
+              </a:rPr>
+              <a:t>/wx-claude-code:questionario</a:t>
+            </a:r>
+            <a:endParaRPr lang="en-US" sz="1100" dirty="0"/>
+          </a:p>
+        </p:txBody>
+      </p:sp>
+      <p:sp>
+        <p:nvSpPr>
+          <p:cNvPr id="12" name="Text 10"/>
+          <p:cNvSpPr txBox="1"/>
+          <p:nvPr/>
+        </p:nvSpPr>
+        <p:spPr>
+          <a:xfrm>
+            <a:off x="3611880" y="3840480"/>
+            <a:ext cx="2286000" cy="1645920"/>
+          </a:xfrm>
+          <a:prstGeom prst="rect">
+            <a:avLst/>
+          </a:prstGeom>
+          <a:noFill/>
+          <a:ln/>
+        </p:spPr>
+        <p:txBody>
+          <a:bodyPr wrap="square" lIns="0" tIns="0" rIns="0" bIns="0" rtlCol="0" anchor="ctr"/>
+          <a:lstStyle/>
+          <a:p>
+            <a:pPr indent="0" marL="0">
+              <a:buNone/>
+            </a:pPr>
+            <a:r>
+              <a:rPr lang="en-US" sz="1300" dirty="0">
+                <a:solidFill>
+                  <a:srgbClr val="6B6F82"/>
+                </a:solidFill>
+                <a:latin typeface="Calibri" pitchFamily="34" charset="0"/>
+                <a:ea typeface="Calibri" pitchFamily="34" charset="-122"/>
+                <a:cs typeface="Calibri" pitchFamily="34" charset="-120"/>
+              </a:rPr>
+              <a:t>Sessenta perguntas, com pausa e retomada. Sai o contexto do projeto.</a:t>
+            </a:r>
+            <a:endParaRPr lang="en-US" sz="1300" dirty="0"/>
+          </a:p>
+        </p:txBody>
+      </p:sp>
+      <p:sp>
+        <p:nvSpPr>
+          <p:cNvPr id="13" name="Shape 11"/>
+          <p:cNvSpPr/>
+          <p:nvPr/>
+        </p:nvSpPr>
+        <p:spPr>
+          <a:xfrm>
+            <a:off x="6217920" y="1463040"/>
+            <a:ext cx="2651760" cy="4206240"/>
+          </a:xfrm>
+          <a:prstGeom prst="roundRect">
+            <a:avLst>
+              <a:gd name="adj" fmla="val 4138"/>
+            </a:avLst>
+          </a:prstGeom>
+          <a:solidFill>
+            <a:srgbClr val="FFFFFF"/>
+          </a:solidFill>
+          <a:ln w="12700">
+            <a:solidFill>
+              <a:srgbClr val="E4E2DB"/>
+            </a:solidFill>
+            <a:prstDash val="solid"/>
+          </a:ln>
+          <a:effectLst>
+            <a:outerShdw sx="100000" sy="100000" kx="0" ky="0" algn="bl" rotWithShape="0" blurRad="76200" dist="25400" dir="5400000">
+              <a:srgbClr val="000000">
+                <a:alpha val="8000"/>
+              </a:srgbClr>
+            </a:outerShdw>
+          </a:effectLst>
+        </p:spPr>
+      </p:sp>
+      <p:sp>
+        <p:nvSpPr>
+          <p:cNvPr id="14" name="Text 12"/>
+          <p:cNvSpPr txBox="1"/>
+          <p:nvPr/>
+        </p:nvSpPr>
+        <p:spPr>
+          <a:xfrm>
+            <a:off x="6446520" y="1645920"/>
+            <a:ext cx="914400" cy="822960"/>
+          </a:xfrm>
+          <a:prstGeom prst="rect">
+            <a:avLst/>
+          </a:prstGeom>
+          <a:noFill/>
+          <a:ln/>
+        </p:spPr>
+        <p:txBody>
+          <a:bodyPr wrap="square" lIns="0" tIns="0" rIns="0" bIns="0" rtlCol="0" anchor="ctr"/>
+          <a:lstStyle/>
+          <a:p>
+            <a:pPr indent="0" marL="0">
+              <a:buNone/>
+            </a:pPr>
+            <a:r>
+              <a:rPr lang="en-US" sz="4400" b="1" dirty="0">
+                <a:solidFill>
+                  <a:srgbClr val="E2261C"/>
+                </a:solidFill>
+                <a:latin typeface="Century Schoolbook" pitchFamily="34" charset="0"/>
+                <a:ea typeface="Century Schoolbook" pitchFamily="34" charset="-122"/>
+                <a:cs typeface="Century Schoolbook" pitchFamily="34" charset="-120"/>
+              </a:rPr>
+              <a:t>3</a:t>
+            </a:r>
+            <a:endParaRPr lang="en-US" sz="4400" dirty="0"/>
+          </a:p>
+        </p:txBody>
+      </p:sp>
+      <p:sp>
+        <p:nvSpPr>
+          <p:cNvPr id="15" name="Text 13"/>
+          <p:cNvSpPr txBox="1"/>
+          <p:nvPr/>
+        </p:nvSpPr>
+        <p:spPr>
+          <a:xfrm>
+            <a:off x="6446520" y="2514600"/>
+            <a:ext cx="2286000" cy="457200"/>
+          </a:xfrm>
+          <a:prstGeom prst="rect">
+            <a:avLst/>
+          </a:prstGeom>
+          <a:noFill/>
+          <a:ln/>
+        </p:spPr>
+        <p:txBody>
+          <a:bodyPr wrap="square" lIns="0" tIns="0" rIns="0" bIns="0" rtlCol="0" anchor="ctr"/>
+          <a:lstStyle/>
+          <a:p>
+            <a:pPr indent="0" marL="0">
+              <a:buNone/>
+            </a:pPr>
+            <a:r>
+              <a:rPr lang="en-US" sz="1800" b="1" dirty="0">
+                <a:solidFill>
+                  <a:srgbClr val="14161F"/>
+                </a:solidFill>
+                <a:latin typeface="Calibri" pitchFamily="34" charset="0"/>
+                <a:ea typeface="Calibri" pitchFamily="34" charset="-122"/>
+                <a:cs typeface="Calibri" pitchFamily="34" charset="-120"/>
+              </a:rPr>
+              <a:t>Passar o G0</a:t>
+            </a:r>
+            <a:endParaRPr lang="en-US" sz="1800" dirty="0"/>
+          </a:p>
+        </p:txBody>
+      </p:sp>
+      <p:sp>
+        <p:nvSpPr>
+          <p:cNvPr id="16" name="Text 14"/>
+          <p:cNvSpPr txBox="1"/>
+          <p:nvPr/>
+        </p:nvSpPr>
+        <p:spPr>
+          <a:xfrm>
+            <a:off x="6446520" y="3017520"/>
+            <a:ext cx="2286000" cy="731520"/>
+          </a:xfrm>
+          <a:prstGeom prst="rect">
+            <a:avLst/>
+          </a:prstGeom>
+          <a:noFill/>
+          <a:ln/>
+        </p:spPr>
+        <p:txBody>
+          <a:bodyPr wrap="square" lIns="0" tIns="0" rIns="0" bIns="0" rtlCol="0" anchor="ctr"/>
+          <a:lstStyle/>
+          <a:p>
+            <a:pPr indent="0" marL="0">
+              <a:buNone/>
+            </a:pPr>
+            <a:r>
+              <a:rPr lang="en-US" sz="1100" dirty="0">
+                <a:solidFill>
+                  <a:srgbClr val="E2261C"/>
+                </a:solidFill>
+                <a:latin typeface="Courier New" pitchFamily="34" charset="0"/>
+                <a:ea typeface="Courier New" pitchFamily="34" charset="-122"/>
+                <a:cs typeface="Courier New" pitchFamily="34" charset="-120"/>
+              </a:rPr>
+              <a:t>/wx-claude-code:preflight</a:t>
+            </a:r>
+            <a:endParaRPr lang="en-US" sz="1100" dirty="0"/>
+          </a:p>
+        </p:txBody>
+      </p:sp>
+      <p:sp>
+        <p:nvSpPr>
+          <p:cNvPr id="17" name="Text 15"/>
+          <p:cNvSpPr txBox="1"/>
+          <p:nvPr/>
+        </p:nvSpPr>
+        <p:spPr>
+          <a:xfrm>
+            <a:off x="6446520" y="3840480"/>
+            <a:ext cx="2286000" cy="1645920"/>
+          </a:xfrm>
+          <a:prstGeom prst="rect">
+            <a:avLst/>
+          </a:prstGeom>
+          <a:noFill/>
+          <a:ln/>
+        </p:spPr>
+        <p:txBody>
+          <a:bodyPr wrap="square" lIns="0" tIns="0" rIns="0" bIns="0" rtlCol="0" anchor="ctr"/>
+          <a:lstStyle/>
+          <a:p>
+            <a:pPr indent="0" marL="0">
+              <a:buNone/>
+            </a:pPr>
+            <a:r>
+              <a:rPr lang="en-US" sz="1300" dirty="0">
+                <a:solidFill>
+                  <a:srgbClr val="6B6F82"/>
+                </a:solidFill>
+                <a:latin typeface="Calibri" pitchFamily="34" charset="0"/>
+                <a:ea typeface="Calibri" pitchFamily="34" charset="-122"/>
+                <a:cs typeface="Calibri" pitchFamily="34" charset="-120"/>
+              </a:rPr>
+              <a:t>Evidências com hash. O relatório diz a classe da prova e o limite.</a:t>
+            </a:r>
+            <a:endParaRPr lang="en-US" sz="1300" dirty="0"/>
+          </a:p>
+        </p:txBody>
+      </p:sp>
+      <p:sp>
+        <p:nvSpPr>
+          <p:cNvPr id="18" name="Shape 16"/>
+          <p:cNvSpPr/>
+          <p:nvPr/>
+        </p:nvSpPr>
+        <p:spPr>
+          <a:xfrm>
+            <a:off x="9052560" y="1463040"/>
+            <a:ext cx="2651760" cy="4206240"/>
+          </a:xfrm>
+          <a:prstGeom prst="roundRect">
+            <a:avLst>
+              <a:gd name="adj" fmla="val 4138"/>
+            </a:avLst>
+          </a:prstGeom>
+          <a:solidFill>
+            <a:srgbClr val="FFFFFF"/>
+          </a:solidFill>
+          <a:ln w="12700">
+            <a:solidFill>
+              <a:srgbClr val="E4E2DB"/>
+            </a:solidFill>
+            <a:prstDash val="solid"/>
+          </a:ln>
+          <a:effectLst>
+            <a:outerShdw sx="100000" sy="100000" kx="0" ky="0" algn="bl" rotWithShape="0" blurRad="76200" dist="25400" dir="5400000">
+              <a:srgbClr val="000000">
+                <a:alpha val="8000"/>
+              </a:srgbClr>
+            </a:outerShdw>
+          </a:effectLst>
+        </p:spPr>
+      </p:sp>
+      <p:sp>
+        <p:nvSpPr>
+          <p:cNvPr id="19" name="Text 17"/>
+          <p:cNvSpPr txBox="1"/>
+          <p:nvPr/>
+        </p:nvSpPr>
+        <p:spPr>
+          <a:xfrm>
+            <a:off x="9281160" y="1645920"/>
+            <a:ext cx="914400" cy="822960"/>
+          </a:xfrm>
+          <a:prstGeom prst="rect">
+            <a:avLst/>
+          </a:prstGeom>
+          <a:noFill/>
+          <a:ln/>
+        </p:spPr>
+        <p:txBody>
+          <a:bodyPr wrap="square" lIns="0" tIns="0" rIns="0" bIns="0" rtlCol="0" anchor="ctr"/>
+          <a:lstStyle/>
+          <a:p>
+            <a:pPr indent="0" marL="0">
+              <a:buNone/>
+            </a:pPr>
+            <a:r>
+              <a:rPr lang="en-US" sz="4400" b="1" dirty="0">
+                <a:solidFill>
+                  <a:srgbClr val="E2261C"/>
+                </a:solidFill>
+                <a:latin typeface="Century Schoolbook" pitchFamily="34" charset="0"/>
+                <a:ea typeface="Century Schoolbook" pitchFamily="34" charset="-122"/>
+                <a:cs typeface="Century Schoolbook" pitchFamily="34" charset="-120"/>
+              </a:rPr>
+              <a:t>4</a:t>
+            </a:r>
+            <a:endParaRPr lang="en-US" sz="4400" dirty="0"/>
+          </a:p>
+        </p:txBody>
+      </p:sp>
+      <p:sp>
+        <p:nvSpPr>
+          <p:cNvPr id="20" name="Text 18"/>
+          <p:cNvSpPr txBox="1"/>
+          <p:nvPr/>
+        </p:nvSpPr>
+        <p:spPr>
+          <a:xfrm>
+            <a:off x="9281160" y="2514600"/>
+            <a:ext cx="2286000" cy="457200"/>
+          </a:xfrm>
+          <a:prstGeom prst="rect">
+            <a:avLst/>
+          </a:prstGeom>
+          <a:noFill/>
+          <a:ln/>
+        </p:spPr>
+        <p:txBody>
+          <a:bodyPr wrap="square" lIns="0" tIns="0" rIns="0" bIns="0" rtlCol="0" anchor="ctr"/>
+          <a:lstStyle/>
+          <a:p>
+            <a:pPr indent="0" marL="0">
+              <a:buNone/>
+            </a:pPr>
+            <a:r>
+              <a:rPr lang="en-US" sz="1800" b="1" dirty="0">
+                <a:solidFill>
+                  <a:srgbClr val="14161F"/>
+                </a:solidFill>
+                <a:latin typeface="Calibri" pitchFamily="34" charset="0"/>
+                <a:ea typeface="Calibri" pitchFamily="34" charset="-122"/>
+                <a:cs typeface="Calibri" pitchFamily="34" charset="-120"/>
+              </a:rPr>
+              <a:t>Piloto com prova</a:t>
+            </a:r>
+            <a:endParaRPr lang="en-US" sz="1800" dirty="0"/>
+          </a:p>
+        </p:txBody>
+      </p:sp>
+      <p:sp>
+        <p:nvSpPr>
+          <p:cNvPr id="21" name="Text 19"/>
+          <p:cNvSpPr txBox="1"/>
+          <p:nvPr/>
+        </p:nvSpPr>
+        <p:spPr>
+          <a:xfrm>
+            <a:off x="9281160" y="3017520"/>
+            <a:ext cx="2286000" cy="731520"/>
+          </a:xfrm>
+          <a:prstGeom prst="rect">
+            <a:avLst/>
+          </a:prstGeom>
+          <a:noFill/>
+          <a:ln/>
+        </p:spPr>
+        <p:txBody>
+          <a:bodyPr wrap="square" lIns="0" tIns="0" rIns="0" bIns="0" rtlCol="0" anchor="ctr"/>
+          <a:lstStyle/>
+          <a:p>
+            <a:pPr indent="0" marL="0">
+              <a:buNone/>
+            </a:pPr>
+            <a:r>
+              <a:rPr lang="en-US" sz="1100" dirty="0">
+                <a:solidFill>
+                  <a:srgbClr val="E2261C"/>
+                </a:solidFill>
+                <a:latin typeface="Courier New" pitchFamily="34" charset="0"/>
+                <a:ea typeface="Courier New" pitchFamily="34" charset="-122"/>
+                <a:cs typeface="Courier New" pitchFamily="34" charset="-120"/>
+              </a:rPr>
+              <a:t>/wx-claude-code:golden comparar</a:t>
+            </a:r>
+            <a:endParaRPr lang="en-US" sz="1100" dirty="0"/>
+          </a:p>
+        </p:txBody>
+      </p:sp>
+      <p:sp>
+        <p:nvSpPr>
+          <p:cNvPr id="22" name="Text 20"/>
+          <p:cNvSpPr txBox="1"/>
+          <p:nvPr/>
+        </p:nvSpPr>
+        <p:spPr>
+          <a:xfrm>
+            <a:off x="9281160" y="3840480"/>
+            <a:ext cx="2286000" cy="1645920"/>
+          </a:xfrm>
+          <a:prstGeom prst="rect">
+            <a:avLst/>
+          </a:prstGeom>
+          <a:noFill/>
+          <a:ln/>
+        </p:spPr>
+        <p:txBody>
+          <a:bodyPr wrap="square" lIns="0" tIns="0" rIns="0" bIns="0" rtlCol="0" anchor="ctr"/>
+          <a:lstStyle/>
+          <a:p>
+            <a:pPr indent="0" marL="0">
+              <a:buNone/>
+            </a:pPr>
+            <a:r>
+              <a:rPr lang="en-US" sz="1300" dirty="0">
+                <a:solidFill>
+                  <a:srgbClr val="6B6F82"/>
+                </a:solidFill>
+                <a:latin typeface="Calibri" pitchFamily="34" charset="0"/>
+                <a:ea typeface="Calibri" pitchFamily="34" charset="-122"/>
+                <a:cs typeface="Calibri" pitchFamily="34" charset="-120"/>
+              </a:rPr>
+              <a:t>Uma vertical inteira, igualdade em número. Daí, as ondas.</a:t>
+            </a:r>
+            <a:endParaRPr lang="en-US" sz="1300" dirty="0"/>
+          </a:p>
+        </p:txBody>
+      </p:sp>
+      <p:sp>
+        <p:nvSpPr>
+          <p:cNvPr id="23" name="Text 21"/>
+          <p:cNvSpPr txBox="1"/>
+          <p:nvPr/>
+        </p:nvSpPr>
+        <p:spPr>
+          <a:xfrm>
+            <a:off x="548640" y="5943600"/>
+            <a:ext cx="11064240" cy="365760"/>
+          </a:xfrm>
+          <a:prstGeom prst="rect">
+            <a:avLst/>
+          </a:prstGeom>
+          <a:noFill/>
+          <a:ln/>
+        </p:spPr>
+        <p:txBody>
+          <a:bodyPr wrap="square" lIns="0" tIns="0" rIns="0" bIns="0" rtlCol="0" anchor="ctr"/>
+          <a:lstStyle/>
+          <a:p>
+            <a:pPr indent="0" marL="0">
+              <a:buNone/>
+            </a:pPr>
+            <a:r>
+              <a:rPr lang="en-US" sz="1200" dirty="0">
+                <a:solidFill>
+                  <a:srgbClr val="6B6F82"/>
+                </a:solidFill>
+                <a:latin typeface="Calibri" pitchFamily="34" charset="0"/>
+                <a:ea typeface="Calibri" pitchFamily="34" charset="-122"/>
+                <a:cs typeface="Calibri" pitchFamily="34" charset="-120"/>
+              </a:rPr>
+              <a:t>Manual: MANUAL.md e docs/manual-de-uso.pdf · Fluxograma: docs/dossie/fluxo-atual.pdf · Vídeos: docs/video/</a:t>
+            </a:r>
+            <a:endParaRPr lang="en-US" sz="1200" dirty="0"/>
+          </a:p>
+        </p:txBody>
+      </p:sp>
+      <p:sp>
+        <p:nvSpPr>
+          <p:cNvPr id="24" name="Text 22"/>
+          <p:cNvSpPr txBox="1"/>
+          <p:nvPr/>
+        </p:nvSpPr>
+        <p:spPr>
+          <a:xfrm>
+            <a:off x="548640" y="6400800"/>
+            <a:ext cx="8229600" cy="274320"/>
+          </a:xfrm>
+          <a:prstGeom prst="rect">
+            <a:avLst/>
+          </a:prstGeom>
+          <a:noFill/>
+          <a:ln/>
+        </p:spPr>
+        <p:txBody>
+          <a:bodyPr wrap="square" lIns="0" tIns="0" rIns="0" bIns="0" rtlCol="0" anchor="ctr"/>
+          <a:lstStyle/>
+          <a:p>
+            <a:pPr indent="0" marL="0">
+              <a:buNone/>
+            </a:pPr>
+            <a:r>
+              <a:rPr lang="en-US" sz="1000" dirty="0">
+                <a:solidFill>
+                  <a:srgbClr val="6B6F82"/>
+                </a:solidFill>
+                <a:latin typeface="Calibri" pitchFamily="34" charset="0"/>
+                <a:ea typeface="Calibri" pitchFamily="34" charset="-122"/>
+                <a:cs typeface="Calibri" pitchFamily="34" charset="-120"/>
+              </a:rPr>
+              <a:t>WX Claude Code 3.48.0 · Built to convert. Engineered to prove.</a:t>
+            </a:r>
+            <a:endParaRPr lang="en-US" sz="1000" dirty="0"/>
+          </a:p>
+        </p:txBody>
+      </p:sp>
+    </p:spTree>
+  </p:cSld>
+  <p:clrMapOvr>
+    <a:masterClrMapping/>
+  </p:clrMapOvr>
+</p:sld>
+</file>
+
+<file path=ppt/slides/slide16.xml><?xml version="1.0" encoding="utf-8"?>
+<p:sld xmlns:a="http://schemas.openxmlformats.org/drawingml/2006/main" xmlns:r="http://schemas.openxmlformats.org/officeDocument/2006/relationships" xmlns:p="http://schemas.openxmlformats.org/presentationml/2006/main">
+  <p:cSld name="Slide 16">
     <p:bg>
       <p:bgPr>
         <a:solidFill>
@@ -4843,7 +6452,7 @@
                 <a:ea typeface="Calibri" pitchFamily="34" charset="-122"/>
                 <a:cs typeface="Calibri" pitchFamily="34" charset="-120"/>
               </a:rPr>
-              <a:t>WX Claude Code 3.46.0 · Built to convert. Engineered to prove.</a:t>
+              <a:t>WX Claude Code 3.48.0 · Built to convert. Engineered to prove.</a:t>
             </a:r>
             <a:endParaRPr lang="en-US" sz="1000" dirty="0"/>
           </a:p>
@@ -5661,7 +7270,7 @@
                 <a:ea typeface="Calibri" pitchFamily="34" charset="-122"/>
                 <a:cs typeface="Calibri" pitchFamily="34" charset="-120"/>
               </a:rPr>
-              <a:t>WX Claude Code 3.46.0 · Built to convert. Engineered to prove.</a:t>
+              <a:t>WX Claude Code 3.48.0 · Built to convert. Engineered to prove.</a:t>
             </a:r>
             <a:endParaRPr lang="en-US" sz="1000" dirty="0"/>
           </a:p>
@@ -6746,7 +8355,7 @@
                 <a:ea typeface="Calibri" pitchFamily="34" charset="-122"/>
                 <a:cs typeface="Calibri" pitchFamily="34" charset="-120"/>
               </a:rPr>
-              <a:t>WX Claude Code 3.46.0 · Built to convert. Engineered to prove.</a:t>
+              <a:t>WX Claude Code 3.48.0 · Built to convert. Engineered to prove.</a:t>
             </a:r>
             <a:endParaRPr lang="en-US" sz="1000" dirty="0"/>
           </a:p>
@@ -7466,7 +9075,7 @@
                 <a:ea typeface="Calibri" pitchFamily="34" charset="-122"/>
                 <a:cs typeface="Calibri" pitchFamily="34" charset="-120"/>
               </a:rPr>
-              <a:t>WX Claude Code 3.46.0 · Built to convert. Engineered to prove.</a:t>
+              <a:t>WX Claude Code 3.48.0 · Built to convert. Engineered to prove.</a:t>
             </a:r>
             <a:endParaRPr lang="en-US" sz="1000" dirty="0"/>
           </a:p>
@@ -7891,7 +9500,7 @@
                 <a:ea typeface="Century Schoolbook" pitchFamily="34" charset="-122"/>
                 <a:cs typeface="Century Schoolbook" pitchFamily="34" charset="-120"/>
               </a:rPr>
-              <a:t>5</a:t>
+              <a:t>7</a:t>
             </a:r>
             <a:endParaRPr lang="en-US" sz="4600" dirty="0"/>
           </a:p>
@@ -8191,7 +9800,7 @@
                 <a:ea typeface="Calibri" pitchFamily="34" charset="-122"/>
                 <a:cs typeface="Calibri" pitchFamily="34" charset="-120"/>
               </a:rPr>
-              <a:t>WX Claude Code 3.46.0 · Built to convert. Engineered to prove.</a:t>
+              <a:t>WX Claude Code 3.48.0 · Built to convert. Engineered to prove.</a:t>
             </a:r>
             <a:endParaRPr lang="en-US" sz="1000" dirty="0"/>
           </a:p>
@@ -8466,7 +10075,7 @@
                 <a:ea typeface="Calibri" pitchFamily="34" charset="-122"/>
                 <a:cs typeface="Calibri" pitchFamily="34" charset="-120"/>
               </a:rPr>
-              <a:t>WX Claude Code 3.46.0 · Built to convert. Engineered to prove.</a:t>
+              <a:t>WX Claude Code 3.48.0 · Built to convert. Engineered to prove.</a:t>
             </a:r>
             <a:endParaRPr lang="en-US" sz="1000" dirty="0"/>
           </a:p>
@@ -9347,7 +10956,7 @@
                 <a:ea typeface="Calibri" pitchFamily="34" charset="-122"/>
                 <a:cs typeface="Calibri" pitchFamily="34" charset="-120"/>
               </a:rPr>
-              <a:t>WX Claude Code 3.46.0 · Built to convert. Engineered to prove.</a:t>
+              <a:t>WX Claude Code 3.48.0 · Built to convert. Engineered to prove.</a:t>
             </a:r>
             <a:endParaRPr lang="en-US" sz="1000" dirty="0"/>
           </a:p>
@@ -9910,7 +11519,7 @@
                 <a:ea typeface="Calibri" pitchFamily="34" charset="-122"/>
                 <a:cs typeface="Calibri" pitchFamily="34" charset="-120"/>
               </a:rPr>
-              <a:t>WX Claude Code 3.46.0 · Built to convert. Engineered to prove.</a:t>
+              <a:t>WX Claude Code 3.48.0 · Built to convert. Engineered to prove.</a:t>
             </a:r>
             <a:endParaRPr lang="en-US" sz="1000" dirty="0"/>
           </a:p>

</xml_diff>